<commit_message>
Update README.md with tips for using Object.keys in JavaScript exercises
</commit_message>
<xml_diff>
--- a/Javascript/JavaScript.pptx
+++ b/Javascript/JavaScript.pptx
@@ -31,6 +31,7 @@
     <p:sldId id="287" r:id="rId33"/>
     <p:sldId id="288" r:id="rId34"/>
     <p:sldId id="289" r:id="rId35"/>
+    <p:sldId id="290" r:id="rId36"/>
     <p:sldId id="283" r:id="rId22"/>
     <p:sldId id="284" r:id="rId23"/>
     <p:sldId id="286" r:id="rId24"/>
@@ -15210,475 +15211,25 @@
               <a:rPr lang="sv-SE" sz="3600" dirty="0">
                 <a:latin typeface="Bodoni MT" panose="02070603080606020203" pitchFamily="18" charset="0"/>
               </a:rPr>
-              <a:t>Objektorienterad programmering</a:t>
+              <a:t>Object.keys, values och entries</a:t>
             </a:r>
           </a:p>
         </p:txBody>
       </p:sp>
       <p:sp>
         <p:nvSpPr>
-          <p:cNvPr id="3" name="Begrepp"/>
-          <p:cNvSpPr txBox="1"/>
-          <p:nvPr/>
-        </p:nvSpPr>
-        <p:spPr>
-          <a:xfrm>
-            <a:off x="1207008" y="914400"/>
-            <a:ext cx="4297680" cy="5394960"/>
-          </a:xfrm>
-          <a:prstGeom prst="rect">
-            <a:avLst/>
-          </a:prstGeom>
-          <a:noFill/>
-          <a:ln>
-            <a:noFill/>
-          </a:ln>
-        </p:spPr>
-        <p:txBody>
-          <a:bodyPr wrap="square" lIns="0" tIns="0" rIns="0" bIns="0" anchor="t" rtlCol="0">
-            <a:noAutofit/>
-          </a:bodyPr>
-          <a:lstStyle/>
-          <a:p>
-            <a:pPr marL="0" indent="0" algn="l">
-              <a:spcBef>
-                <a:spcPts val="0"/>
-              </a:spcBef>
-              <a:spcAft>
-                <a:spcPts val="1000"/>
-              </a:spcAft>
-              <a:buNone/>
-            </a:pPr>
-            <a:r>
-              <a:rPr lang="sv-SE" sz="1800" dirty="0">
-                <a:solidFill>
-                  <a:srgbClr val="404040"/>
-                </a:solidFill>
-              </a:rPr>
-              <a:t>I OOP samlar vi data och funktioner som hör ihop i objekt.</a:t>
-            </a:r>
-          </a:p>
-          <a:p>
-            <a:pPr marL="0" indent="0" algn="l">
-              <a:spcBef>
-                <a:spcPts val="1000"/>
-              </a:spcBef>
-              <a:spcAft>
-                <a:spcPts val="0"/>
-              </a:spcAft>
-              <a:buNone/>
-            </a:pPr>
-            <a:r>
-              <a:rPr lang="sv-SE" sz="1700" b="1" dirty="0">
-                <a:solidFill>
-                  <a:srgbClr val="2A1A00"/>
-                </a:solidFill>
-              </a:rPr>
-              <a:t>Klass</a:t>
-            </a:r>
-          </a:p>
-          <a:p>
-            <a:pPr marL="0" indent="0" algn="l">
-              <a:spcBef>
-                <a:spcPts val="0"/>
-              </a:spcBef>
-              <a:spcAft>
-                <a:spcPts val="0"/>
-              </a:spcAft>
-              <a:buNone/>
-            </a:pPr>
-            <a:r>
-              <a:rPr lang="sv-SE" sz="1600" dirty="0">
-                <a:solidFill>
-                  <a:srgbClr val="404040"/>
-                </a:solidFill>
-              </a:rPr>
-              <a:t>En mall eller ritning, som receptet för en glass.</a:t>
-            </a:r>
-          </a:p>
-          <a:p>
-            <a:pPr marL="0" indent="0" algn="l">
-              <a:spcBef>
-                <a:spcPts val="1000"/>
-              </a:spcBef>
-              <a:spcAft>
-                <a:spcPts val="0"/>
-              </a:spcAft>
-              <a:buNone/>
-            </a:pPr>
-            <a:r>
-              <a:rPr lang="sv-SE" sz="1700" b="1" dirty="0">
-                <a:solidFill>
-                  <a:srgbClr val="2A1A00"/>
-                </a:solidFill>
-              </a:rPr>
-              <a:t>Objekt / instans</a:t>
-            </a:r>
-          </a:p>
-          <a:p>
-            <a:pPr marL="0" indent="0" algn="l">
-              <a:spcBef>
-                <a:spcPts val="0"/>
-              </a:spcBef>
-              <a:spcAft>
-                <a:spcPts val="0"/>
-              </a:spcAft>
-              <a:buNone/>
-            </a:pPr>
-            <a:r>
-              <a:rPr lang="sv-SE" sz="1600" dirty="0">
-                <a:solidFill>
-                  <a:srgbClr val="404040"/>
-                </a:solidFill>
-              </a:rPr>
-              <a:t>En riktig glass som skapas från klassen.</a:t>
-            </a:r>
-          </a:p>
-          <a:p>
-            <a:pPr marL="0" indent="0" algn="l">
-              <a:spcBef>
-                <a:spcPts val="1000"/>
-              </a:spcBef>
-              <a:spcAft>
-                <a:spcPts val="0"/>
-              </a:spcAft>
-              <a:buNone/>
-            </a:pPr>
-            <a:r>
-              <a:rPr lang="sv-SE" sz="1700" b="1" dirty="0">
-                <a:solidFill>
-                  <a:srgbClr val="2A1A00"/>
-                </a:solidFill>
-              </a:rPr>
-              <a:t>Egenskaper</a:t>
-            </a:r>
-          </a:p>
-          <a:p>
-            <a:pPr marL="0" indent="0" algn="l">
-              <a:spcBef>
-                <a:spcPts val="0"/>
-              </a:spcBef>
-              <a:spcAft>
-                <a:spcPts val="0"/>
-              </a:spcAft>
-              <a:buNone/>
-            </a:pPr>
-            <a:r>
-              <a:rPr lang="sv-SE" sz="1600" dirty="0">
-                <a:solidFill>
-                  <a:srgbClr val="404040"/>
-                </a:solidFill>
-              </a:rPr>
-              <a:t>Data som objektet har, t.ex. smak och kulor.</a:t>
-            </a:r>
-          </a:p>
-          <a:p>
-            <a:pPr marL="0" indent="0" algn="l">
-              <a:spcBef>
-                <a:spcPts val="1000"/>
-              </a:spcBef>
-              <a:spcAft>
-                <a:spcPts val="0"/>
-              </a:spcAft>
-              <a:buNone/>
-            </a:pPr>
-            <a:r>
-              <a:rPr lang="sv-SE" sz="1700" b="1" dirty="0">
-                <a:solidFill>
-                  <a:srgbClr val="2A1A00"/>
-                </a:solidFill>
-              </a:rPr>
-              <a:t>Metoder</a:t>
-            </a:r>
-          </a:p>
-          <a:p>
-            <a:pPr marL="0" indent="0" algn="l">
-              <a:spcBef>
-                <a:spcPts val="0"/>
-              </a:spcBef>
-              <a:spcAft>
-                <a:spcPts val="0"/>
-              </a:spcAft>
-              <a:buNone/>
-            </a:pPr>
-            <a:r>
-              <a:rPr lang="sv-SE" sz="1600" dirty="0">
-                <a:solidFill>
-                  <a:srgbClr val="404040"/>
-                </a:solidFill>
-              </a:rPr>
-              <a:t>Saker objektet kan göra, t.ex. beskriv().</a:t>
-            </a:r>
-          </a:p>
-          <a:p>
-            <a:pPr marL="0" indent="0" algn="l">
-              <a:spcBef>
-                <a:spcPts val="1800"/>
-              </a:spcBef>
-              <a:spcAft>
-                <a:spcPts val="0"/>
-              </a:spcAft>
-              <a:buNone/>
-            </a:pPr>
-            <a:r>
-              <a:rPr lang="sv-SE" sz="1600" i="1" dirty="0">
-                <a:solidFill>
-                  <a:srgbClr val="6B6B6B"/>
-                </a:solidFill>
-              </a:rPr>
-              <a:t>En klass, många objekt. Varje objekt har sina egna värden.</a:t>
-            </a:r>
-          </a:p>
-        </p:txBody>
-      </p:sp>
-      <p:sp>
-        <p:nvSpPr>
-          <p:cNvPr id="4" name="Klass Glass"/>
+          <p:cNvPr id="3" name="Kod"/>
           <p:cNvSpPr/>
           <p:nvPr/>
         </p:nvSpPr>
         <p:spPr>
           <a:xfrm>
-            <a:off x="6766560" y="914400"/>
-            <a:ext cx="3840480" cy="1417320"/>
+            <a:off x="1207008" y="868680"/>
+            <a:ext cx="6858000" cy="1672336"/>
           </a:xfrm>
           <a:prstGeom prst="roundRect">
             <a:avLst>
-              <a:gd name="adj" fmla="val 8000"/>
-            </a:avLst>
-          </a:prstGeom>
-          <a:solidFill>
-            <a:srgbClr val="F8B323"/>
-          </a:solidFill>
-          <a:ln>
-            <a:noFill/>
-          </a:ln>
-          <a:effectLst>
-            <a:outerShdw blurRad="76200" dist="25400" dir="5400000" algn="t" rotWithShape="0">
-              <a:srgbClr val="000000">
-                <a:alpha val="18000"/>
-              </a:srgbClr>
-            </a:outerShdw>
-          </a:effectLst>
-        </p:spPr>
-        <p:txBody>
-          <a:bodyPr wrap="square" lIns="182880" tIns="73152" rIns="182880" bIns="73152" anchor="ctr" rtlCol="0">
-            <a:noAutofit/>
-          </a:bodyPr>
-          <a:lstStyle/>
-          <a:p>
-            <a:pPr marL="0" indent="0" algn="ctr">
-              <a:spcBef>
-                <a:spcPts val="0"/>
-              </a:spcBef>
-              <a:spcAft>
-                <a:spcPts val="0"/>
-              </a:spcAft>
-              <a:buNone/>
-            </a:pPr>
-            <a:r>
-              <a:rPr lang="sv-SE" sz="1100" b="1" dirty="0">
-                <a:solidFill>
-                  <a:srgbClr val="2A1A00"/>
-                </a:solidFill>
-              </a:rPr>
-              <a:t>KLASS</a:t>
-            </a:r>
-          </a:p>
-          <a:p>
-            <a:pPr marL="0" indent="0" algn="ctr">
-              <a:spcBef>
-                <a:spcPts val="0"/>
-              </a:spcBef>
-              <a:spcAft>
-                <a:spcPts val="0"/>
-              </a:spcAft>
-              <a:buNone/>
-            </a:pPr>
-            <a:r>
-              <a:rPr lang="sv-SE" sz="2400" b="1" dirty="0">
-                <a:solidFill>
-                  <a:srgbClr val="2A1A00"/>
-                </a:solidFill>
-              </a:rPr>
-              <a:t>Glass</a:t>
-            </a:r>
-          </a:p>
-          <a:p>
-            <a:pPr marL="0" indent="0" algn="ctr">
-              <a:spcBef>
-                <a:spcPts val="0"/>
-              </a:spcBef>
-              <a:spcAft>
-                <a:spcPts val="0"/>
-              </a:spcAft>
-              <a:buNone/>
-            </a:pPr>
-            <a:r>
-              <a:rPr lang="sv-SE" sz="1200" dirty="0">
-                <a:solidFill>
-                  <a:srgbClr val="2A1A00"/>
-                </a:solidFill>
-                <a:latin typeface="Courier New"/>
-                <a:cs typeface="Courier New"/>
-              </a:rPr>
-              <a:t>smak · kulor · pris() · beskriv()</a:t>
-            </a:r>
-          </a:p>
-        </p:txBody>
-      </p:sp>
-      <p:sp>
-        <p:nvSpPr>
-          <p:cNvPr id="5" name="Pil"/>
-          <p:cNvSpPr/>
-          <p:nvPr/>
-        </p:nvSpPr>
-        <p:spPr>
-          <a:xfrm>
-            <a:off x="6611112" y="2450592"/>
-            <a:ext cx="219456" cy="411480"/>
-          </a:xfrm>
-          <a:prstGeom prst="downArrow">
-            <a:avLst/>
-          </a:prstGeom>
-          <a:solidFill>
-            <a:srgbClr val="B8B8B6"/>
-          </a:solidFill>
-          <a:ln>
-            <a:noFill/>
-          </a:ln>
-        </p:spPr>
-        <p:txBody>
-          <a:bodyPr wrap="square" lIns="91440" tIns="45720" rIns="91440" bIns="45720" anchor="t" rtlCol="0">
-            <a:noAutofit/>
-          </a:bodyPr>
-          <a:lstStyle/>
-          <a:p>
-            <a:endParaRPr lang="sv-SE" dirty="0"/>
-          </a:p>
-        </p:txBody>
-      </p:sp>
-      <p:sp>
-        <p:nvSpPr>
-          <p:cNvPr id="6" name="Pil"/>
-          <p:cNvSpPr/>
-          <p:nvPr/>
-        </p:nvSpPr>
-        <p:spPr>
-          <a:xfrm>
-            <a:off x="8577072" y="2450592"/>
-            <a:ext cx="219456" cy="411480"/>
-          </a:xfrm>
-          <a:prstGeom prst="downArrow">
-            <a:avLst/>
-          </a:prstGeom>
-          <a:solidFill>
-            <a:srgbClr val="B8B8B6"/>
-          </a:solidFill>
-          <a:ln>
-            <a:noFill/>
-          </a:ln>
-        </p:spPr>
-        <p:txBody>
-          <a:bodyPr wrap="square" lIns="91440" tIns="45720" rIns="91440" bIns="45720" anchor="t" rtlCol="0">
-            <a:noAutofit/>
-          </a:bodyPr>
-          <a:lstStyle/>
-          <a:p>
-            <a:endParaRPr lang="sv-SE" dirty="0"/>
-          </a:p>
-        </p:txBody>
-      </p:sp>
-      <p:sp>
-        <p:nvSpPr>
-          <p:cNvPr id="7" name="Pil"/>
-          <p:cNvSpPr/>
-          <p:nvPr/>
-        </p:nvSpPr>
-        <p:spPr>
-          <a:xfrm>
-            <a:off x="10543032" y="2450592"/>
-            <a:ext cx="219456" cy="411480"/>
-          </a:xfrm>
-          <a:prstGeom prst="downArrow">
-            <a:avLst/>
-          </a:prstGeom>
-          <a:solidFill>
-            <a:srgbClr val="B8B8B6"/>
-          </a:solidFill>
-          <a:ln>
-            <a:noFill/>
-          </a:ln>
-        </p:spPr>
-        <p:txBody>
-          <a:bodyPr wrap="square" lIns="91440" tIns="45720" rIns="91440" bIns="45720" anchor="t" rtlCol="0">
-            <a:noAutofit/>
-          </a:bodyPr>
-          <a:lstStyle/>
-          <a:p>
-            <a:endParaRPr lang="sv-SE" dirty="0"/>
-          </a:p>
-        </p:txBody>
-      </p:sp>
-      <p:sp>
-        <p:nvSpPr>
-          <p:cNvPr id="8" name="Etikett new"/>
-          <p:cNvSpPr txBox="1"/>
-          <p:nvPr/>
-        </p:nvSpPr>
-        <p:spPr>
-          <a:xfrm>
-            <a:off x="5897880" y="2880360"/>
-            <a:ext cx="5577840" cy="274320"/>
-          </a:xfrm>
-          <a:prstGeom prst="rect">
-            <a:avLst/>
-          </a:prstGeom>
-          <a:noFill/>
-          <a:ln>
-            <a:noFill/>
-          </a:ln>
-        </p:spPr>
-        <p:txBody>
-          <a:bodyPr wrap="square" lIns="0" tIns="0" rIns="0" bIns="0" anchor="t" rtlCol="0">
-            <a:noAutofit/>
-          </a:bodyPr>
-          <a:lstStyle/>
-          <a:p>
-            <a:pPr marL="0" indent="0" algn="ctr">
-              <a:spcBef>
-                <a:spcPts val="0"/>
-              </a:spcBef>
-              <a:spcAft>
-                <a:spcPts val="0"/>
-              </a:spcAft>
-              <a:buNone/>
-            </a:pPr>
-            <a:r>
-              <a:rPr lang="sv-SE" sz="1200" i="1" dirty="0">
-                <a:solidFill>
-                  <a:srgbClr val="6B6B6B"/>
-                </a:solidFill>
-              </a:rPr>
-              <a:t>skapar objekt (instanser)</a:t>
-            </a:r>
-          </a:p>
-        </p:txBody>
-      </p:sp>
-      <p:sp>
-        <p:nvSpPr>
-          <p:cNvPr id="9" name="Objekt glass1"/>
-          <p:cNvSpPr/>
-          <p:nvPr/>
-        </p:nvSpPr>
-        <p:spPr>
-          <a:xfrm>
-            <a:off x="5897880" y="3246120"/>
-            <a:ext cx="1645920" cy="2606040"/>
-          </a:xfrm>
-          <a:prstGeom prst="roundRect">
-            <a:avLst>
-              <a:gd name="adj" fmla="val 7000"/>
+              <a:gd name="adj" fmla="val 3500"/>
             </a:avLst>
           </a:prstGeom>
           <a:solidFill>
@@ -15696,124 +15247,577 @@
           </a:effectLst>
         </p:spPr>
         <p:txBody>
-          <a:bodyPr wrap="square" lIns="91440" tIns="45720" rIns="91440" bIns="45720" anchor="t" rtlCol="0">
+          <a:bodyPr wrap="square" lIns="274320" tIns="201168" rIns="274320" bIns="201168" anchor="t" rtlCol="0">
             <a:noAutofit/>
           </a:bodyPr>
           <a:lstStyle/>
           <a:p>
-            <a:endParaRPr lang="sv-SE" dirty="0"/>
+            <a:pPr marL="0" indent="0" algn="l">
+              <a:lnSpc>
+                <a:spcPts val="2000"/>
+              </a:lnSpc>
+              <a:spcBef>
+                <a:spcPts val="0"/>
+              </a:spcBef>
+              <a:spcAft>
+                <a:spcPts val="0"/>
+              </a:spcAft>
+              <a:buNone/>
+            </a:pPr>
+            <a:r>
+              <a:rPr lang="sv-SE" sz="1300" dirty="0">
+                <a:solidFill>
+                  <a:srgbClr val="A626A4"/>
+                </a:solidFill>
+                <a:latin typeface="Courier New"/>
+                <a:cs typeface="Courier New"/>
+              </a:rPr>
+              <a:t>const</a:t>
+            </a:r>
+            <a:r>
+              <a:rPr lang="sv-SE" sz="1300" dirty="0">
+                <a:solidFill>
+                  <a:srgbClr val="383A42"/>
+                </a:solidFill>
+                <a:latin typeface="Courier New"/>
+                <a:cs typeface="Courier New"/>
+              </a:rPr>
+              <a:t xml:space="preserve"> </a:t>
+            </a:r>
+            <a:r>
+              <a:rPr lang="sv-SE" sz="1300" dirty="0">
+                <a:solidFill>
+                  <a:srgbClr val="383A42"/>
+                </a:solidFill>
+                <a:latin typeface="Courier New"/>
+                <a:cs typeface="Courier New"/>
+              </a:rPr>
+              <a:t>glass</a:t>
+            </a:r>
+            <a:r>
+              <a:rPr lang="sv-SE" sz="1300" dirty="0">
+                <a:solidFill>
+                  <a:srgbClr val="383A42"/>
+                </a:solidFill>
+                <a:latin typeface="Courier New"/>
+                <a:cs typeface="Courier New"/>
+              </a:rPr>
+              <a:t xml:space="preserve"> </a:t>
+            </a:r>
+            <a:r>
+              <a:rPr lang="sv-SE" sz="1300" dirty="0">
+                <a:solidFill>
+                  <a:srgbClr val="383A42"/>
+                </a:solidFill>
+                <a:latin typeface="Courier New"/>
+                <a:cs typeface="Courier New"/>
+              </a:rPr>
+              <a:t>=</a:t>
+            </a:r>
+            <a:r>
+              <a:rPr lang="sv-SE" sz="1300" dirty="0">
+                <a:solidFill>
+                  <a:srgbClr val="383A42"/>
+                </a:solidFill>
+                <a:latin typeface="Courier New"/>
+                <a:cs typeface="Courier New"/>
+              </a:rPr>
+              <a:t xml:space="preserve"> </a:t>
+            </a:r>
+            <a:r>
+              <a:rPr lang="sv-SE" sz="1300" dirty="0">
+                <a:solidFill>
+                  <a:srgbClr val="383A42"/>
+                </a:solidFill>
+                <a:latin typeface="Courier New"/>
+                <a:cs typeface="Courier New"/>
+              </a:rPr>
+              <a:t>{</a:t>
+            </a:r>
+            <a:r>
+              <a:rPr lang="sv-SE" sz="1300" dirty="0">
+                <a:solidFill>
+                  <a:srgbClr val="383A42"/>
+                </a:solidFill>
+                <a:latin typeface="Courier New"/>
+                <a:cs typeface="Courier New"/>
+              </a:rPr>
+              <a:t xml:space="preserve"> </a:t>
+            </a:r>
+            <a:r>
+              <a:rPr lang="sv-SE" sz="1300" dirty="0">
+                <a:solidFill>
+                  <a:srgbClr val="383A42"/>
+                </a:solidFill>
+                <a:latin typeface="Courier New"/>
+                <a:cs typeface="Courier New"/>
+              </a:rPr>
+              <a:t>smak</a:t>
+            </a:r>
+            <a:r>
+              <a:rPr lang="sv-SE" sz="1300" dirty="0">
+                <a:solidFill>
+                  <a:srgbClr val="383A42"/>
+                </a:solidFill>
+                <a:latin typeface="Courier New"/>
+                <a:cs typeface="Courier New"/>
+              </a:rPr>
+              <a:t>:</a:t>
+            </a:r>
+            <a:r>
+              <a:rPr lang="sv-SE" sz="1300" dirty="0">
+                <a:solidFill>
+                  <a:srgbClr val="383A42"/>
+                </a:solidFill>
+                <a:latin typeface="Courier New"/>
+                <a:cs typeface="Courier New"/>
+              </a:rPr>
+              <a:t xml:space="preserve"> </a:t>
+            </a:r>
+            <a:r>
+              <a:rPr lang="sv-SE" sz="1300" dirty="0">
+                <a:solidFill>
+                  <a:srgbClr val="3F9A3E"/>
+                </a:solidFill>
+                <a:latin typeface="Courier New"/>
+                <a:cs typeface="Courier New"/>
+              </a:rPr>
+              <a:t>"Choklad"</a:t>
+            </a:r>
+            <a:r>
+              <a:rPr lang="sv-SE" sz="1300" dirty="0">
+                <a:solidFill>
+                  <a:srgbClr val="383A42"/>
+                </a:solidFill>
+                <a:latin typeface="Courier New"/>
+                <a:cs typeface="Courier New"/>
+              </a:rPr>
+              <a:t>,</a:t>
+            </a:r>
+            <a:r>
+              <a:rPr lang="sv-SE" sz="1300" dirty="0">
+                <a:solidFill>
+                  <a:srgbClr val="383A42"/>
+                </a:solidFill>
+                <a:latin typeface="Courier New"/>
+                <a:cs typeface="Courier New"/>
+              </a:rPr>
+              <a:t xml:space="preserve"> </a:t>
+            </a:r>
+            <a:r>
+              <a:rPr lang="sv-SE" sz="1300" dirty="0">
+                <a:solidFill>
+                  <a:srgbClr val="383A42"/>
+                </a:solidFill>
+                <a:latin typeface="Courier New"/>
+                <a:cs typeface="Courier New"/>
+              </a:rPr>
+              <a:t>kulor</a:t>
+            </a:r>
+            <a:r>
+              <a:rPr lang="sv-SE" sz="1300" dirty="0">
+                <a:solidFill>
+                  <a:srgbClr val="383A42"/>
+                </a:solidFill>
+                <a:latin typeface="Courier New"/>
+                <a:cs typeface="Courier New"/>
+              </a:rPr>
+              <a:t>:</a:t>
+            </a:r>
+            <a:r>
+              <a:rPr lang="sv-SE" sz="1300" dirty="0">
+                <a:solidFill>
+                  <a:srgbClr val="383A42"/>
+                </a:solidFill>
+                <a:latin typeface="Courier New"/>
+                <a:cs typeface="Courier New"/>
+              </a:rPr>
+              <a:t xml:space="preserve"> </a:t>
+            </a:r>
+            <a:r>
+              <a:rPr lang="sv-SE" sz="1300" dirty="0">
+                <a:solidFill>
+                  <a:srgbClr val="B26B00"/>
+                </a:solidFill>
+                <a:latin typeface="Courier New"/>
+                <a:cs typeface="Courier New"/>
+              </a:rPr>
+              <a:t>2</a:t>
+            </a:r>
+            <a:r>
+              <a:rPr lang="sv-SE" sz="1300" dirty="0">
+                <a:solidFill>
+                  <a:srgbClr val="383A42"/>
+                </a:solidFill>
+                <a:latin typeface="Courier New"/>
+                <a:cs typeface="Courier New"/>
+              </a:rPr>
+              <a:t xml:space="preserve"> </a:t>
+            </a:r>
+            <a:r>
+              <a:rPr lang="sv-SE" sz="1300" dirty="0">
+                <a:solidFill>
+                  <a:srgbClr val="383A42"/>
+                </a:solidFill>
+                <a:latin typeface="Courier New"/>
+                <a:cs typeface="Courier New"/>
+              </a:rPr>
+              <a:t>}</a:t>
+            </a:r>
+            <a:r>
+              <a:rPr lang="sv-SE" sz="1300" dirty="0">
+                <a:solidFill>
+                  <a:srgbClr val="383A42"/>
+                </a:solidFill>
+                <a:latin typeface="Courier New"/>
+                <a:cs typeface="Courier New"/>
+              </a:rPr>
+              <a:t>;</a:t>
+            </a:r>
+            <a:endParaRPr lang="sv-SE" sz="1300" dirty="0"/>
+          </a:p>
+          <a:p>
+            <a:pPr marL="0" indent="0" algn="l">
+              <a:lnSpc>
+                <a:spcPts val="2000"/>
+              </a:lnSpc>
+              <a:spcBef>
+                <a:spcPts val="0"/>
+              </a:spcBef>
+              <a:spcAft>
+                <a:spcPts val="0"/>
+              </a:spcAft>
+              <a:buNone/>
+            </a:pPr>
+            <a:endParaRPr lang="sv-SE" sz="1300" dirty="0"/>
+          </a:p>
+          <a:p>
+            <a:pPr marL="0" indent="0" algn="l">
+              <a:lnSpc>
+                <a:spcPts val="2000"/>
+              </a:lnSpc>
+              <a:spcBef>
+                <a:spcPts val="0"/>
+              </a:spcBef>
+              <a:spcAft>
+                <a:spcPts val="0"/>
+              </a:spcAft>
+              <a:buNone/>
+            </a:pPr>
+            <a:r>
+              <a:rPr lang="sv-SE" sz="1300" dirty="0">
+                <a:solidFill>
+                  <a:srgbClr val="383A42"/>
+                </a:solidFill>
+                <a:latin typeface="Courier New"/>
+                <a:cs typeface="Courier New"/>
+              </a:rPr>
+              <a:t>Object</a:t>
+            </a:r>
+            <a:r>
+              <a:rPr lang="sv-SE" sz="1300" dirty="0">
+                <a:solidFill>
+                  <a:srgbClr val="383A42"/>
+                </a:solidFill>
+                <a:latin typeface="Courier New"/>
+                <a:cs typeface="Courier New"/>
+              </a:rPr>
+              <a:t>.</a:t>
+            </a:r>
+            <a:r>
+              <a:rPr lang="sv-SE" sz="1300" dirty="0">
+                <a:solidFill>
+                  <a:srgbClr val="C0761B"/>
+                </a:solidFill>
+                <a:latin typeface="Courier New"/>
+                <a:cs typeface="Courier New"/>
+              </a:rPr>
+              <a:t>keys</a:t>
+            </a:r>
+            <a:r>
+              <a:rPr lang="sv-SE" sz="1300" dirty="0">
+                <a:solidFill>
+                  <a:srgbClr val="383A42"/>
+                </a:solidFill>
+                <a:latin typeface="Courier New"/>
+                <a:cs typeface="Courier New"/>
+              </a:rPr>
+              <a:t>(</a:t>
+            </a:r>
+            <a:r>
+              <a:rPr lang="sv-SE" sz="1300" dirty="0">
+                <a:solidFill>
+                  <a:srgbClr val="383A42"/>
+                </a:solidFill>
+                <a:latin typeface="Courier New"/>
+                <a:cs typeface="Courier New"/>
+              </a:rPr>
+              <a:t>glass</a:t>
+            </a:r>
+            <a:r>
+              <a:rPr lang="sv-SE" sz="1300" dirty="0">
+                <a:solidFill>
+                  <a:srgbClr val="383A42"/>
+                </a:solidFill>
+                <a:latin typeface="Courier New"/>
+                <a:cs typeface="Courier New"/>
+              </a:rPr>
+              <a:t>)</a:t>
+            </a:r>
+            <a:r>
+              <a:rPr lang="sv-SE" sz="1300" dirty="0">
+                <a:solidFill>
+                  <a:srgbClr val="383A42"/>
+                </a:solidFill>
+                <a:latin typeface="Courier New"/>
+                <a:cs typeface="Courier New"/>
+              </a:rPr>
+              <a:t>;</a:t>
+            </a:r>
+            <a:r>
+              <a:rPr lang="sv-SE" sz="1300" dirty="0">
+                <a:solidFill>
+                  <a:srgbClr val="383A42"/>
+                </a:solidFill>
+                <a:latin typeface="Courier New"/>
+                <a:cs typeface="Courier New"/>
+              </a:rPr>
+              <a:t xml:space="preserve">    </a:t>
+            </a:r>
+            <a:r>
+              <a:rPr lang="sv-SE" sz="1300" i="1" dirty="0">
+                <a:solidFill>
+                  <a:srgbClr val="8A8F98"/>
+                </a:solidFill>
+                <a:latin typeface="Courier New"/>
+                <a:cs typeface="Courier New"/>
+              </a:rPr>
+              <a:t>// ["smak", "kulor"]</a:t>
+            </a:r>
+            <a:endParaRPr lang="sv-SE" sz="1300" dirty="0"/>
+          </a:p>
+          <a:p>
+            <a:pPr marL="0" indent="0" algn="l">
+              <a:lnSpc>
+                <a:spcPts val="2000"/>
+              </a:lnSpc>
+              <a:spcBef>
+                <a:spcPts val="0"/>
+              </a:spcBef>
+              <a:spcAft>
+                <a:spcPts val="0"/>
+              </a:spcAft>
+              <a:buNone/>
+            </a:pPr>
+            <a:r>
+              <a:rPr lang="sv-SE" sz="1300" dirty="0">
+                <a:solidFill>
+                  <a:srgbClr val="383A42"/>
+                </a:solidFill>
+                <a:latin typeface="Courier New"/>
+                <a:cs typeface="Courier New"/>
+              </a:rPr>
+              <a:t>Object</a:t>
+            </a:r>
+            <a:r>
+              <a:rPr lang="sv-SE" sz="1300" dirty="0">
+                <a:solidFill>
+                  <a:srgbClr val="383A42"/>
+                </a:solidFill>
+                <a:latin typeface="Courier New"/>
+                <a:cs typeface="Courier New"/>
+              </a:rPr>
+              <a:t>.</a:t>
+            </a:r>
+            <a:r>
+              <a:rPr lang="sv-SE" sz="1300" dirty="0">
+                <a:solidFill>
+                  <a:srgbClr val="C0761B"/>
+                </a:solidFill>
+                <a:latin typeface="Courier New"/>
+                <a:cs typeface="Courier New"/>
+              </a:rPr>
+              <a:t>values</a:t>
+            </a:r>
+            <a:r>
+              <a:rPr lang="sv-SE" sz="1300" dirty="0">
+                <a:solidFill>
+                  <a:srgbClr val="383A42"/>
+                </a:solidFill>
+                <a:latin typeface="Courier New"/>
+                <a:cs typeface="Courier New"/>
+              </a:rPr>
+              <a:t>(</a:t>
+            </a:r>
+            <a:r>
+              <a:rPr lang="sv-SE" sz="1300" dirty="0">
+                <a:solidFill>
+                  <a:srgbClr val="383A42"/>
+                </a:solidFill>
+                <a:latin typeface="Courier New"/>
+                <a:cs typeface="Courier New"/>
+              </a:rPr>
+              <a:t>glass</a:t>
+            </a:r>
+            <a:r>
+              <a:rPr lang="sv-SE" sz="1300" dirty="0">
+                <a:solidFill>
+                  <a:srgbClr val="383A42"/>
+                </a:solidFill>
+                <a:latin typeface="Courier New"/>
+                <a:cs typeface="Courier New"/>
+              </a:rPr>
+              <a:t>)</a:t>
+            </a:r>
+            <a:r>
+              <a:rPr lang="sv-SE" sz="1300" dirty="0">
+                <a:solidFill>
+                  <a:srgbClr val="383A42"/>
+                </a:solidFill>
+                <a:latin typeface="Courier New"/>
+                <a:cs typeface="Courier New"/>
+              </a:rPr>
+              <a:t>;</a:t>
+            </a:r>
+            <a:r>
+              <a:rPr lang="sv-SE" sz="1300" dirty="0">
+                <a:solidFill>
+                  <a:srgbClr val="383A42"/>
+                </a:solidFill>
+                <a:latin typeface="Courier New"/>
+                <a:cs typeface="Courier New"/>
+              </a:rPr>
+              <a:t xml:space="preserve">  </a:t>
+            </a:r>
+            <a:r>
+              <a:rPr lang="sv-SE" sz="1300" i="1" dirty="0">
+                <a:solidFill>
+                  <a:srgbClr val="8A8F98"/>
+                </a:solidFill>
+                <a:latin typeface="Courier New"/>
+                <a:cs typeface="Courier New"/>
+              </a:rPr>
+              <a:t>// ["Choklad", 2]</a:t>
+            </a:r>
+            <a:endParaRPr lang="sv-SE" sz="1300" dirty="0"/>
+          </a:p>
+          <a:p>
+            <a:pPr marL="0" indent="0" algn="l">
+              <a:lnSpc>
+                <a:spcPts val="2000"/>
+              </a:lnSpc>
+              <a:spcBef>
+                <a:spcPts val="0"/>
+              </a:spcBef>
+              <a:spcAft>
+                <a:spcPts val="0"/>
+              </a:spcAft>
+              <a:buNone/>
+            </a:pPr>
+            <a:r>
+              <a:rPr lang="sv-SE" sz="1300" dirty="0">
+                <a:solidFill>
+                  <a:srgbClr val="383A42"/>
+                </a:solidFill>
+                <a:latin typeface="Courier New"/>
+                <a:cs typeface="Courier New"/>
+              </a:rPr>
+              <a:t>Object</a:t>
+            </a:r>
+            <a:r>
+              <a:rPr lang="sv-SE" sz="1300" dirty="0">
+                <a:solidFill>
+                  <a:srgbClr val="383A42"/>
+                </a:solidFill>
+                <a:latin typeface="Courier New"/>
+                <a:cs typeface="Courier New"/>
+              </a:rPr>
+              <a:t>.</a:t>
+            </a:r>
+            <a:r>
+              <a:rPr lang="sv-SE" sz="1300" dirty="0">
+                <a:solidFill>
+                  <a:srgbClr val="C0761B"/>
+                </a:solidFill>
+                <a:latin typeface="Courier New"/>
+                <a:cs typeface="Courier New"/>
+              </a:rPr>
+              <a:t>entries</a:t>
+            </a:r>
+            <a:r>
+              <a:rPr lang="sv-SE" sz="1300" dirty="0">
+                <a:solidFill>
+                  <a:srgbClr val="383A42"/>
+                </a:solidFill>
+                <a:latin typeface="Courier New"/>
+                <a:cs typeface="Courier New"/>
+              </a:rPr>
+              <a:t>(</a:t>
+            </a:r>
+            <a:r>
+              <a:rPr lang="sv-SE" sz="1300" dirty="0">
+                <a:solidFill>
+                  <a:srgbClr val="383A42"/>
+                </a:solidFill>
+                <a:latin typeface="Courier New"/>
+                <a:cs typeface="Courier New"/>
+              </a:rPr>
+              <a:t>glass</a:t>
+            </a:r>
+            <a:r>
+              <a:rPr lang="sv-SE" sz="1300" dirty="0">
+                <a:solidFill>
+                  <a:srgbClr val="383A42"/>
+                </a:solidFill>
+                <a:latin typeface="Courier New"/>
+                <a:cs typeface="Courier New"/>
+              </a:rPr>
+              <a:t>)</a:t>
+            </a:r>
+            <a:r>
+              <a:rPr lang="sv-SE" sz="1300" dirty="0">
+                <a:solidFill>
+                  <a:srgbClr val="383A42"/>
+                </a:solidFill>
+                <a:latin typeface="Courier New"/>
+                <a:cs typeface="Courier New"/>
+              </a:rPr>
+              <a:t>;</a:t>
+            </a:r>
+            <a:r>
+              <a:rPr lang="sv-SE" sz="1300" dirty="0">
+                <a:solidFill>
+                  <a:srgbClr val="383A42"/>
+                </a:solidFill>
+                <a:latin typeface="Courier New"/>
+                <a:cs typeface="Courier New"/>
+              </a:rPr>
+              <a:t xml:space="preserve"> </a:t>
+            </a:r>
+            <a:r>
+              <a:rPr lang="sv-SE" sz="1300" i="1" dirty="0">
+                <a:solidFill>
+                  <a:srgbClr val="8A8F98"/>
+                </a:solidFill>
+                <a:latin typeface="Courier New"/>
+                <a:cs typeface="Courier New"/>
+              </a:rPr>
+              <a:t>// [["smak", "Choklad"], ["kulor", 2]]</a:t>
+            </a:r>
+            <a:endParaRPr lang="sv-SE" sz="1300" dirty="0"/>
           </a:p>
         </p:txBody>
       </p:sp>
       <p:sp>
         <p:nvSpPr>
-          <p:cNvPr id="10" name="Strut"/>
-          <p:cNvSpPr/>
-          <p:nvPr/>
-        </p:nvSpPr>
-        <p:spPr>
-          <a:xfrm flipV="1">
-            <a:off x="6503670" y="4444898"/>
-            <a:ext cx="434340" cy="538582"/>
-          </a:xfrm>
-          <a:prstGeom prst="triangle">
-            <a:avLst/>
-          </a:prstGeom>
-          <a:solidFill>
-            <a:srgbClr val="D9A25F"/>
-          </a:solidFill>
-          <a:ln w="12700">
-            <a:solidFill>
-              <a:srgbClr val="B7803F"/>
-            </a:solidFill>
-          </a:ln>
-        </p:spPr>
-        <p:txBody>
-          <a:bodyPr wrap="square" lIns="91440" tIns="45720" rIns="91440" bIns="45720" anchor="t" rtlCol="0">
-            <a:noAutofit/>
-          </a:bodyPr>
-          <a:lstStyle/>
-          <a:p>
-            <a:endParaRPr lang="sv-SE" dirty="0"/>
-          </a:p>
-        </p:txBody>
-      </p:sp>
-      <p:sp>
-        <p:nvSpPr>
-          <p:cNvPr id="11" name="Kula 1"/>
-          <p:cNvSpPr/>
-          <p:nvPr/>
-        </p:nvSpPr>
-        <p:spPr>
-          <a:xfrm>
-            <a:off x="6521044" y="4157192"/>
-            <a:ext cx="399593" cy="399593"/>
-          </a:xfrm>
-          <a:prstGeom prst="ellipse">
-            <a:avLst/>
-          </a:prstGeom>
-          <a:solidFill>
-            <a:srgbClr val="6B3E26"/>
-          </a:solidFill>
-          <a:ln w="12700">
-            <a:solidFill>
-              <a:srgbClr val="FFFFFF"/>
-            </a:solidFill>
-          </a:ln>
-        </p:spPr>
-        <p:txBody>
-          <a:bodyPr wrap="square" lIns="91440" tIns="45720" rIns="91440" bIns="45720" anchor="t" rtlCol="0">
-            <a:noAutofit/>
-          </a:bodyPr>
-          <a:lstStyle/>
-          <a:p>
-            <a:endParaRPr lang="sv-SE" dirty="0"/>
-          </a:p>
-        </p:txBody>
-      </p:sp>
-      <p:sp>
-        <p:nvSpPr>
-          <p:cNvPr id="12" name="Kula 2"/>
-          <p:cNvSpPr/>
-          <p:nvPr/>
-        </p:nvSpPr>
-        <p:spPr>
-          <a:xfrm>
-            <a:off x="6521044" y="3909444"/>
-            <a:ext cx="399593" cy="399593"/>
-          </a:xfrm>
-          <a:prstGeom prst="ellipse">
-            <a:avLst/>
-          </a:prstGeom>
-          <a:solidFill>
-            <a:srgbClr val="6B3E26"/>
-          </a:solidFill>
-          <a:ln w="12700">
-            <a:solidFill>
-              <a:srgbClr val="FFFFFF"/>
-            </a:solidFill>
-          </a:ln>
-        </p:spPr>
-        <p:txBody>
-          <a:bodyPr wrap="square" lIns="91440" tIns="45720" rIns="91440" bIns="45720" anchor="t" rtlCol="0">
-            <a:noAutofit/>
-          </a:bodyPr>
-          <a:lstStyle/>
-          <a:p>
-            <a:endParaRPr lang="sv-SE" dirty="0"/>
-          </a:p>
-        </p:txBody>
-      </p:sp>
-      <p:sp>
-        <p:nvSpPr>
-          <p:cNvPr id="13" name="Text glass1"/>
+          <p:cNvPr id="4" name="Rubrik tomt"/>
           <p:cNvSpPr txBox="1"/>
           <p:nvPr/>
         </p:nvSpPr>
         <p:spPr>
           <a:xfrm>
-            <a:off x="5989320" y="5074920"/>
-            <a:ext cx="1463040" cy="914400"/>
+            <a:off x="1207008" y="2861056"/>
+            <a:ext cx="6858000" cy="365760"/>
           </a:xfrm>
           <a:prstGeom prst="rect">
             <a:avLst/>
@@ -15829,7 +15833,7 @@
           </a:bodyPr>
           <a:lstStyle/>
           <a:p>
-            <a:pPr marL="0" indent="0" algn="ctr">
+            <a:pPr marL="0" indent="0" algn="l">
               <a:spcBef>
                 <a:spcPts val="0"/>
               </a:spcBef>
@@ -15839,51 +15843,30 @@
               <a:buNone/>
             </a:pPr>
             <a:r>
-              <a:rPr lang="sv-SE" sz="1300" b="1" dirty="0">
+              <a:rPr lang="sv-SE" sz="1800" b="1" dirty="0">
                 <a:solidFill>
                   <a:srgbClr val="2A1A00"/>
                 </a:solidFill>
-                <a:latin typeface="Courier New"/>
-                <a:cs typeface="Courier New"/>
-              </a:rPr>
-              <a:t>glass1</a:t>
-            </a:r>
-          </a:p>
-          <a:p>
-            <a:pPr marL="0" indent="0" algn="ctr">
-              <a:spcBef>
-                <a:spcPts val="0"/>
-              </a:spcBef>
-              <a:spcAft>
-                <a:spcPts val="0"/>
-              </a:spcAft>
-              <a:buNone/>
-            </a:pPr>
-            <a:r>
-              <a:rPr lang="sv-SE" sz="1300" dirty="0">
-                <a:solidFill>
-                  <a:srgbClr val="404040"/>
-                </a:solidFill>
-              </a:rPr>
-              <a:t>Choklad, 2 kulor</a:t>
+              </a:rPr>
+              <a:t>Kolla om ett objekt är tomt</a:t>
             </a:r>
           </a:p>
         </p:txBody>
       </p:sp>
       <p:sp>
         <p:nvSpPr>
-          <p:cNvPr id="14" name="Objekt glass2"/>
+          <p:cNvPr id="5" name="Kod"/>
           <p:cNvSpPr/>
           <p:nvPr/>
         </p:nvSpPr>
         <p:spPr>
           <a:xfrm>
-            <a:off x="7863840" y="3246120"/>
-            <a:ext cx="1645920" cy="2606040"/>
+            <a:off x="1207008" y="3318256"/>
+            <a:ext cx="6858000" cy="1926336"/>
           </a:xfrm>
           <a:prstGeom prst="roundRect">
             <a:avLst>
-              <a:gd name="adj" fmla="val 7000"/>
+              <a:gd name="adj" fmla="val 3500"/>
             </a:avLst>
           </a:prstGeom>
           <a:solidFill>
@@ -15901,173 +15884,15 @@
           </a:effectLst>
         </p:spPr>
         <p:txBody>
-          <a:bodyPr wrap="square" lIns="91440" tIns="45720" rIns="91440" bIns="45720" anchor="t" rtlCol="0">
+          <a:bodyPr wrap="square" lIns="274320" tIns="201168" rIns="274320" bIns="201168" anchor="t" rtlCol="0">
             <a:noAutofit/>
           </a:bodyPr>
           <a:lstStyle/>
           <a:p>
-            <a:endParaRPr lang="sv-SE" dirty="0"/>
-          </a:p>
-        </p:txBody>
-      </p:sp>
-      <p:sp>
-        <p:nvSpPr>
-          <p:cNvPr id="15" name="Strut"/>
-          <p:cNvSpPr/>
-          <p:nvPr/>
-        </p:nvSpPr>
-        <p:spPr>
-          <a:xfrm flipV="1">
-            <a:off x="8469630" y="4444898"/>
-            <a:ext cx="434340" cy="538582"/>
-          </a:xfrm>
-          <a:prstGeom prst="triangle">
-            <a:avLst/>
-          </a:prstGeom>
-          <a:solidFill>
-            <a:srgbClr val="D9A25F"/>
-          </a:solidFill>
-          <a:ln w="12700">
-            <a:solidFill>
-              <a:srgbClr val="B7803F"/>
-            </a:solidFill>
-          </a:ln>
-        </p:spPr>
-        <p:txBody>
-          <a:bodyPr wrap="square" lIns="91440" tIns="45720" rIns="91440" bIns="45720" anchor="t" rtlCol="0">
-            <a:noAutofit/>
-          </a:bodyPr>
-          <a:lstStyle/>
-          <a:p>
-            <a:endParaRPr lang="sv-SE" dirty="0"/>
-          </a:p>
-        </p:txBody>
-      </p:sp>
-      <p:sp>
-        <p:nvSpPr>
-          <p:cNvPr id="16" name="Kula 1"/>
-          <p:cNvSpPr/>
-          <p:nvPr/>
-        </p:nvSpPr>
-        <p:spPr>
-          <a:xfrm>
-            <a:off x="8487004" y="4157192"/>
-            <a:ext cx="399593" cy="399593"/>
-          </a:xfrm>
-          <a:prstGeom prst="ellipse">
-            <a:avLst/>
-          </a:prstGeom>
-          <a:solidFill>
-            <a:srgbClr val="F29CB3"/>
-          </a:solidFill>
-          <a:ln w="12700">
-            <a:solidFill>
-              <a:srgbClr val="FFFFFF"/>
-            </a:solidFill>
-          </a:ln>
-        </p:spPr>
-        <p:txBody>
-          <a:bodyPr wrap="square" lIns="91440" tIns="45720" rIns="91440" bIns="45720" anchor="t" rtlCol="0">
-            <a:noAutofit/>
-          </a:bodyPr>
-          <a:lstStyle/>
-          <a:p>
-            <a:endParaRPr lang="sv-SE" dirty="0"/>
-          </a:p>
-        </p:txBody>
-      </p:sp>
-      <p:sp>
-        <p:nvSpPr>
-          <p:cNvPr id="17" name="Kula 2"/>
-          <p:cNvSpPr/>
-          <p:nvPr/>
-        </p:nvSpPr>
-        <p:spPr>
-          <a:xfrm>
-            <a:off x="8487004" y="3909444"/>
-            <a:ext cx="399593" cy="399593"/>
-          </a:xfrm>
-          <a:prstGeom prst="ellipse">
-            <a:avLst/>
-          </a:prstGeom>
-          <a:solidFill>
-            <a:srgbClr val="F29CB3"/>
-          </a:solidFill>
-          <a:ln w="12700">
-            <a:solidFill>
-              <a:srgbClr val="FFFFFF"/>
-            </a:solidFill>
-          </a:ln>
-        </p:spPr>
-        <p:txBody>
-          <a:bodyPr wrap="square" lIns="91440" tIns="45720" rIns="91440" bIns="45720" anchor="t" rtlCol="0">
-            <a:noAutofit/>
-          </a:bodyPr>
-          <a:lstStyle/>
-          <a:p>
-            <a:endParaRPr lang="sv-SE" dirty="0"/>
-          </a:p>
-        </p:txBody>
-      </p:sp>
-      <p:sp>
-        <p:nvSpPr>
-          <p:cNvPr id="18" name="Kula 3"/>
-          <p:cNvSpPr/>
-          <p:nvPr/>
-        </p:nvSpPr>
-        <p:spPr>
-          <a:xfrm>
-            <a:off x="8487004" y="3661697"/>
-            <a:ext cx="399593" cy="399593"/>
-          </a:xfrm>
-          <a:prstGeom prst="ellipse">
-            <a:avLst/>
-          </a:prstGeom>
-          <a:solidFill>
-            <a:srgbClr val="F29CB3"/>
-          </a:solidFill>
-          <a:ln w="12700">
-            <a:solidFill>
-              <a:srgbClr val="FFFFFF"/>
-            </a:solidFill>
-          </a:ln>
-        </p:spPr>
-        <p:txBody>
-          <a:bodyPr wrap="square" lIns="91440" tIns="45720" rIns="91440" bIns="45720" anchor="t" rtlCol="0">
-            <a:noAutofit/>
-          </a:bodyPr>
-          <a:lstStyle/>
-          <a:p>
-            <a:endParaRPr lang="sv-SE" dirty="0"/>
-          </a:p>
-        </p:txBody>
-      </p:sp>
-      <p:sp>
-        <p:nvSpPr>
-          <p:cNvPr id="19" name="Text glass2"/>
-          <p:cNvSpPr txBox="1"/>
-          <p:nvPr/>
-        </p:nvSpPr>
-        <p:spPr>
-          <a:xfrm>
-            <a:off x="7955280" y="5074920"/>
-            <a:ext cx="1463040" cy="914400"/>
-          </a:xfrm>
-          <a:prstGeom prst="rect">
-            <a:avLst/>
-          </a:prstGeom>
-          <a:noFill/>
-          <a:ln>
-            <a:noFill/>
-          </a:ln>
-        </p:spPr>
-        <p:txBody>
-          <a:bodyPr wrap="square" lIns="0" tIns="0" rIns="0" bIns="0" anchor="t" rtlCol="0">
-            <a:noAutofit/>
-          </a:bodyPr>
-          <a:lstStyle/>
-          <a:p>
-            <a:pPr marL="0" indent="0" algn="ctr">
+            <a:pPr marL="0" indent="0" algn="l">
+              <a:lnSpc>
+                <a:spcPts val="2000"/>
+              </a:lnSpc>
               <a:spcBef>
                 <a:spcPts val="0"/>
               </a:spcBef>
@@ -16077,18 +15902,92 @@
               <a:buNone/>
             </a:pPr>
             <a:r>
-              <a:rPr lang="sv-SE" sz="1300" b="1" dirty="0">
-                <a:solidFill>
-                  <a:srgbClr val="2A1A00"/>
-                </a:solidFill>
-                <a:latin typeface="Courier New"/>
-                <a:cs typeface="Courier New"/>
-              </a:rPr>
-              <a:t>glass2</a:t>
-            </a:r>
-          </a:p>
-          <a:p>
-            <a:pPr marL="0" indent="0" algn="ctr">
+              <a:rPr lang="sv-SE" sz="1300" dirty="0">
+                <a:solidFill>
+                  <a:srgbClr val="A626A4"/>
+                </a:solidFill>
+                <a:latin typeface="Courier New"/>
+                <a:cs typeface="Courier New"/>
+              </a:rPr>
+              <a:t>function</a:t>
+            </a:r>
+            <a:r>
+              <a:rPr lang="sv-SE" sz="1300" dirty="0">
+                <a:solidFill>
+                  <a:srgbClr val="383A42"/>
+                </a:solidFill>
+                <a:latin typeface="Courier New"/>
+                <a:cs typeface="Courier New"/>
+              </a:rPr>
+              <a:t xml:space="preserve"> </a:t>
+            </a:r>
+            <a:r>
+              <a:rPr lang="sv-SE" sz="1300" dirty="0">
+                <a:solidFill>
+                  <a:srgbClr val="C0761B"/>
+                </a:solidFill>
+                <a:latin typeface="Courier New"/>
+                <a:cs typeface="Courier New"/>
+              </a:rPr>
+              <a:t>isEmpty</a:t>
+            </a:r>
+            <a:r>
+              <a:rPr lang="sv-SE" sz="1300" dirty="0">
+                <a:solidFill>
+                  <a:srgbClr val="383A42"/>
+                </a:solidFill>
+                <a:latin typeface="Courier New"/>
+                <a:cs typeface="Courier New"/>
+              </a:rPr>
+              <a:t>(</a:t>
+            </a:r>
+            <a:r>
+              <a:rPr lang="sv-SE" sz="1300" dirty="0">
+                <a:solidFill>
+                  <a:srgbClr val="383A42"/>
+                </a:solidFill>
+                <a:latin typeface="Courier New"/>
+                <a:cs typeface="Courier New"/>
+              </a:rPr>
+              <a:t>obj</a:t>
+            </a:r>
+            <a:r>
+              <a:rPr lang="sv-SE" sz="1300" dirty="0">
+                <a:solidFill>
+                  <a:srgbClr val="383A42"/>
+                </a:solidFill>
+                <a:latin typeface="Courier New"/>
+                <a:cs typeface="Courier New"/>
+              </a:rPr>
+              <a:t>)</a:t>
+            </a:r>
+            <a:r>
+              <a:rPr lang="sv-SE" sz="1300" dirty="0">
+                <a:solidFill>
+                  <a:srgbClr val="383A42"/>
+                </a:solidFill>
+                <a:latin typeface="Courier New"/>
+                <a:cs typeface="Courier New"/>
+              </a:rPr>
+              <a:t xml:space="preserve"> </a:t>
+            </a:r>
+            <a:r>
+              <a:rPr lang="sv-SE" sz="1300" dirty="0">
+                <a:solidFill>
+                  <a:srgbClr val="383A42"/>
+                </a:solidFill>
+                <a:latin typeface="Courier New"/>
+                <a:cs typeface="Courier New"/>
+              </a:rPr>
+              <a:t>{</a:t>
+            </a:r>
+            <a:endParaRPr lang="sv-SE" sz="1300" dirty="0"/>
+          </a:p>
+          <a:p>
+            <a:pPr marL="0" indent="0" algn="l">
+              <a:lnSpc>
+                <a:spcPts val="2000"/>
+              </a:lnSpc>
               <a:spcBef>
                 <a:spcPts val="0"/>
               </a:spcBef>
@@ -16100,28 +15999,521 @@
             <a:r>
               <a:rPr lang="sv-SE" sz="1300" dirty="0">
                 <a:solidFill>
-                  <a:srgbClr val="404040"/>
-                </a:solidFill>
-              </a:rPr>
-              <a:t>Jordgubb, 3 kulor</a:t>
-            </a:r>
+                  <a:srgbClr val="383A42"/>
+                </a:solidFill>
+                <a:latin typeface="Courier New"/>
+                <a:cs typeface="Courier New"/>
+              </a:rPr>
+              <a:t xml:space="preserve">  </a:t>
+            </a:r>
+            <a:r>
+              <a:rPr lang="sv-SE" sz="1300" dirty="0">
+                <a:solidFill>
+                  <a:srgbClr val="A626A4"/>
+                </a:solidFill>
+                <a:latin typeface="Courier New"/>
+                <a:cs typeface="Courier New"/>
+              </a:rPr>
+              <a:t>return</a:t>
+            </a:r>
+            <a:r>
+              <a:rPr lang="sv-SE" sz="1300" dirty="0">
+                <a:solidFill>
+                  <a:srgbClr val="383A42"/>
+                </a:solidFill>
+                <a:latin typeface="Courier New"/>
+                <a:cs typeface="Courier New"/>
+              </a:rPr>
+              <a:t xml:space="preserve"> </a:t>
+            </a:r>
+            <a:r>
+              <a:rPr lang="sv-SE" sz="1300" dirty="0">
+                <a:solidFill>
+                  <a:srgbClr val="383A42"/>
+                </a:solidFill>
+                <a:latin typeface="Courier New"/>
+                <a:cs typeface="Courier New"/>
+              </a:rPr>
+              <a:t>Object</a:t>
+            </a:r>
+            <a:r>
+              <a:rPr lang="sv-SE" sz="1300" dirty="0">
+                <a:solidFill>
+                  <a:srgbClr val="383A42"/>
+                </a:solidFill>
+                <a:latin typeface="Courier New"/>
+                <a:cs typeface="Courier New"/>
+              </a:rPr>
+              <a:t>.</a:t>
+            </a:r>
+            <a:r>
+              <a:rPr lang="sv-SE" sz="1300" dirty="0">
+                <a:solidFill>
+                  <a:srgbClr val="C0761B"/>
+                </a:solidFill>
+                <a:latin typeface="Courier New"/>
+                <a:cs typeface="Courier New"/>
+              </a:rPr>
+              <a:t>keys</a:t>
+            </a:r>
+            <a:r>
+              <a:rPr lang="sv-SE" sz="1300" dirty="0">
+                <a:solidFill>
+                  <a:srgbClr val="383A42"/>
+                </a:solidFill>
+                <a:latin typeface="Courier New"/>
+                <a:cs typeface="Courier New"/>
+              </a:rPr>
+              <a:t>(</a:t>
+            </a:r>
+            <a:r>
+              <a:rPr lang="sv-SE" sz="1300" dirty="0">
+                <a:solidFill>
+                  <a:srgbClr val="383A42"/>
+                </a:solidFill>
+                <a:latin typeface="Courier New"/>
+                <a:cs typeface="Courier New"/>
+              </a:rPr>
+              <a:t>obj</a:t>
+            </a:r>
+            <a:r>
+              <a:rPr lang="sv-SE" sz="1300" dirty="0">
+                <a:solidFill>
+                  <a:srgbClr val="383A42"/>
+                </a:solidFill>
+                <a:latin typeface="Courier New"/>
+                <a:cs typeface="Courier New"/>
+              </a:rPr>
+              <a:t>)</a:t>
+            </a:r>
+            <a:r>
+              <a:rPr lang="sv-SE" sz="1300" dirty="0">
+                <a:solidFill>
+                  <a:srgbClr val="383A42"/>
+                </a:solidFill>
+                <a:latin typeface="Courier New"/>
+                <a:cs typeface="Courier New"/>
+              </a:rPr>
+              <a:t>.</a:t>
+            </a:r>
+            <a:r>
+              <a:rPr lang="sv-SE" sz="1300" dirty="0">
+                <a:solidFill>
+                  <a:srgbClr val="383A42"/>
+                </a:solidFill>
+                <a:latin typeface="Courier New"/>
+                <a:cs typeface="Courier New"/>
+              </a:rPr>
+              <a:t>length</a:t>
+            </a:r>
+            <a:r>
+              <a:rPr lang="sv-SE" sz="1300" dirty="0">
+                <a:solidFill>
+                  <a:srgbClr val="383A42"/>
+                </a:solidFill>
+                <a:latin typeface="Courier New"/>
+                <a:cs typeface="Courier New"/>
+              </a:rPr>
+              <a:t xml:space="preserve"> </a:t>
+            </a:r>
+            <a:r>
+              <a:rPr lang="sv-SE" sz="1300" dirty="0">
+                <a:solidFill>
+                  <a:srgbClr val="383A42"/>
+                </a:solidFill>
+                <a:latin typeface="Courier New"/>
+                <a:cs typeface="Courier New"/>
+              </a:rPr>
+              <a:t>=</a:t>
+            </a:r>
+            <a:r>
+              <a:rPr lang="sv-SE" sz="1300" dirty="0">
+                <a:solidFill>
+                  <a:srgbClr val="383A42"/>
+                </a:solidFill>
+                <a:latin typeface="Courier New"/>
+                <a:cs typeface="Courier New"/>
+              </a:rPr>
+              <a:t>=</a:t>
+            </a:r>
+            <a:r>
+              <a:rPr lang="sv-SE" sz="1300" dirty="0">
+                <a:solidFill>
+                  <a:srgbClr val="383A42"/>
+                </a:solidFill>
+                <a:latin typeface="Courier New"/>
+                <a:cs typeface="Courier New"/>
+              </a:rPr>
+              <a:t>=</a:t>
+            </a:r>
+            <a:r>
+              <a:rPr lang="sv-SE" sz="1300" dirty="0">
+                <a:solidFill>
+                  <a:srgbClr val="383A42"/>
+                </a:solidFill>
+                <a:latin typeface="Courier New"/>
+                <a:cs typeface="Courier New"/>
+              </a:rPr>
+              <a:t xml:space="preserve"> </a:t>
+            </a:r>
+            <a:r>
+              <a:rPr lang="sv-SE" sz="1300" dirty="0">
+                <a:solidFill>
+                  <a:srgbClr val="B26B00"/>
+                </a:solidFill>
+                <a:latin typeface="Courier New"/>
+                <a:cs typeface="Courier New"/>
+              </a:rPr>
+              <a:t>0</a:t>
+            </a:r>
+            <a:r>
+              <a:rPr lang="sv-SE" sz="1300" dirty="0">
+                <a:solidFill>
+                  <a:srgbClr val="383A42"/>
+                </a:solidFill>
+                <a:latin typeface="Courier New"/>
+                <a:cs typeface="Courier New"/>
+              </a:rPr>
+              <a:t>;</a:t>
+            </a:r>
+            <a:endParaRPr lang="sv-SE" sz="1300" dirty="0"/>
+          </a:p>
+          <a:p>
+            <a:pPr marL="0" indent="0" algn="l">
+              <a:lnSpc>
+                <a:spcPts val="2000"/>
+              </a:lnSpc>
+              <a:spcBef>
+                <a:spcPts val="0"/>
+              </a:spcBef>
+              <a:spcAft>
+                <a:spcPts val="0"/>
+              </a:spcAft>
+              <a:buNone/>
+            </a:pPr>
+            <a:r>
+              <a:rPr lang="sv-SE" sz="1300" dirty="0">
+                <a:solidFill>
+                  <a:srgbClr val="383A42"/>
+                </a:solidFill>
+                <a:latin typeface="Courier New"/>
+                <a:cs typeface="Courier New"/>
+              </a:rPr>
+              <a:t>}</a:t>
+            </a:r>
+            <a:endParaRPr lang="sv-SE" sz="1300" dirty="0"/>
+          </a:p>
+          <a:p>
+            <a:pPr marL="0" indent="0" algn="l">
+              <a:lnSpc>
+                <a:spcPts val="2000"/>
+              </a:lnSpc>
+              <a:spcBef>
+                <a:spcPts val="0"/>
+              </a:spcBef>
+              <a:spcAft>
+                <a:spcPts val="0"/>
+              </a:spcAft>
+              <a:buNone/>
+            </a:pPr>
+            <a:endParaRPr lang="sv-SE" sz="1300" dirty="0"/>
+          </a:p>
+          <a:p>
+            <a:pPr marL="0" indent="0" algn="l">
+              <a:lnSpc>
+                <a:spcPts val="2000"/>
+              </a:lnSpc>
+              <a:spcBef>
+                <a:spcPts val="0"/>
+              </a:spcBef>
+              <a:spcAft>
+                <a:spcPts val="0"/>
+              </a:spcAft>
+              <a:buNone/>
+            </a:pPr>
+            <a:r>
+              <a:rPr lang="sv-SE" sz="1300" dirty="0">
+                <a:solidFill>
+                  <a:srgbClr val="383A42"/>
+                </a:solidFill>
+                <a:latin typeface="Courier New"/>
+                <a:cs typeface="Courier New"/>
+              </a:rPr>
+              <a:t>console</a:t>
+            </a:r>
+            <a:r>
+              <a:rPr lang="sv-SE" sz="1300" dirty="0">
+                <a:solidFill>
+                  <a:srgbClr val="383A42"/>
+                </a:solidFill>
+                <a:latin typeface="Courier New"/>
+                <a:cs typeface="Courier New"/>
+              </a:rPr>
+              <a:t>.</a:t>
+            </a:r>
+            <a:r>
+              <a:rPr lang="sv-SE" sz="1300" dirty="0">
+                <a:solidFill>
+                  <a:srgbClr val="C0761B"/>
+                </a:solidFill>
+                <a:latin typeface="Courier New"/>
+                <a:cs typeface="Courier New"/>
+              </a:rPr>
+              <a:t>log</a:t>
+            </a:r>
+            <a:r>
+              <a:rPr lang="sv-SE" sz="1300" dirty="0">
+                <a:solidFill>
+                  <a:srgbClr val="383A42"/>
+                </a:solidFill>
+                <a:latin typeface="Courier New"/>
+                <a:cs typeface="Courier New"/>
+              </a:rPr>
+              <a:t>(</a:t>
+            </a:r>
+            <a:r>
+              <a:rPr lang="sv-SE" sz="1300" dirty="0">
+                <a:solidFill>
+                  <a:srgbClr val="C0761B"/>
+                </a:solidFill>
+                <a:latin typeface="Courier New"/>
+                <a:cs typeface="Courier New"/>
+              </a:rPr>
+              <a:t>isEmpty</a:t>
+            </a:r>
+            <a:r>
+              <a:rPr lang="sv-SE" sz="1300" dirty="0">
+                <a:solidFill>
+                  <a:srgbClr val="383A42"/>
+                </a:solidFill>
+                <a:latin typeface="Courier New"/>
+                <a:cs typeface="Courier New"/>
+              </a:rPr>
+              <a:t>(</a:t>
+            </a:r>
+            <a:r>
+              <a:rPr lang="sv-SE" sz="1300" dirty="0">
+                <a:solidFill>
+                  <a:srgbClr val="383A42"/>
+                </a:solidFill>
+                <a:latin typeface="Courier New"/>
+                <a:cs typeface="Courier New"/>
+              </a:rPr>
+              <a:t>{</a:t>
+            </a:r>
+            <a:r>
+              <a:rPr lang="sv-SE" sz="1300" dirty="0">
+                <a:solidFill>
+                  <a:srgbClr val="383A42"/>
+                </a:solidFill>
+                <a:latin typeface="Courier New"/>
+                <a:cs typeface="Courier New"/>
+              </a:rPr>
+              <a:t>}</a:t>
+            </a:r>
+            <a:r>
+              <a:rPr lang="sv-SE" sz="1300" dirty="0">
+                <a:solidFill>
+                  <a:srgbClr val="383A42"/>
+                </a:solidFill>
+                <a:latin typeface="Courier New"/>
+                <a:cs typeface="Courier New"/>
+              </a:rPr>
+              <a:t>)</a:t>
+            </a:r>
+            <a:r>
+              <a:rPr lang="sv-SE" sz="1300" dirty="0">
+                <a:solidFill>
+                  <a:srgbClr val="383A42"/>
+                </a:solidFill>
+                <a:latin typeface="Courier New"/>
+                <a:cs typeface="Courier New"/>
+              </a:rPr>
+              <a:t>)</a:t>
+            </a:r>
+            <a:r>
+              <a:rPr lang="sv-SE" sz="1300" dirty="0">
+                <a:solidFill>
+                  <a:srgbClr val="383A42"/>
+                </a:solidFill>
+                <a:latin typeface="Courier New"/>
+                <a:cs typeface="Courier New"/>
+              </a:rPr>
+              <a:t>;</a:t>
+            </a:r>
+            <a:r>
+              <a:rPr lang="sv-SE" sz="1300" dirty="0">
+                <a:solidFill>
+                  <a:srgbClr val="383A42"/>
+                </a:solidFill>
+                <a:latin typeface="Courier New"/>
+                <a:cs typeface="Courier New"/>
+              </a:rPr>
+              <a:t xml:space="preserve">     </a:t>
+            </a:r>
+            <a:r>
+              <a:rPr lang="sv-SE" sz="1300" i="1" dirty="0">
+                <a:solidFill>
+                  <a:srgbClr val="8A8F98"/>
+                </a:solidFill>
+                <a:latin typeface="Courier New"/>
+                <a:cs typeface="Courier New"/>
+              </a:rPr>
+              <a:t>// true</a:t>
+            </a:r>
+            <a:endParaRPr lang="sv-SE" sz="1300" dirty="0"/>
+          </a:p>
+          <a:p>
+            <a:pPr marL="0" indent="0" algn="l">
+              <a:lnSpc>
+                <a:spcPts val="2000"/>
+              </a:lnSpc>
+              <a:spcBef>
+                <a:spcPts val="0"/>
+              </a:spcBef>
+              <a:spcAft>
+                <a:spcPts val="0"/>
+              </a:spcAft>
+              <a:buNone/>
+            </a:pPr>
+            <a:r>
+              <a:rPr lang="sv-SE" sz="1300" dirty="0">
+                <a:solidFill>
+                  <a:srgbClr val="383A42"/>
+                </a:solidFill>
+                <a:latin typeface="Courier New"/>
+                <a:cs typeface="Courier New"/>
+              </a:rPr>
+              <a:t>console</a:t>
+            </a:r>
+            <a:r>
+              <a:rPr lang="sv-SE" sz="1300" dirty="0">
+                <a:solidFill>
+                  <a:srgbClr val="383A42"/>
+                </a:solidFill>
+                <a:latin typeface="Courier New"/>
+                <a:cs typeface="Courier New"/>
+              </a:rPr>
+              <a:t>.</a:t>
+            </a:r>
+            <a:r>
+              <a:rPr lang="sv-SE" sz="1300" dirty="0">
+                <a:solidFill>
+                  <a:srgbClr val="C0761B"/>
+                </a:solidFill>
+                <a:latin typeface="Courier New"/>
+                <a:cs typeface="Courier New"/>
+              </a:rPr>
+              <a:t>log</a:t>
+            </a:r>
+            <a:r>
+              <a:rPr lang="sv-SE" sz="1300" dirty="0">
+                <a:solidFill>
+                  <a:srgbClr val="383A42"/>
+                </a:solidFill>
+                <a:latin typeface="Courier New"/>
+                <a:cs typeface="Courier New"/>
+              </a:rPr>
+              <a:t>(</a:t>
+            </a:r>
+            <a:r>
+              <a:rPr lang="sv-SE" sz="1300" dirty="0">
+                <a:solidFill>
+                  <a:srgbClr val="C0761B"/>
+                </a:solidFill>
+                <a:latin typeface="Courier New"/>
+                <a:cs typeface="Courier New"/>
+              </a:rPr>
+              <a:t>isEmpty</a:t>
+            </a:r>
+            <a:r>
+              <a:rPr lang="sv-SE" sz="1300" dirty="0">
+                <a:solidFill>
+                  <a:srgbClr val="383A42"/>
+                </a:solidFill>
+                <a:latin typeface="Courier New"/>
+                <a:cs typeface="Courier New"/>
+              </a:rPr>
+              <a:t>(</a:t>
+            </a:r>
+            <a:r>
+              <a:rPr lang="sv-SE" sz="1300" dirty="0">
+                <a:solidFill>
+                  <a:srgbClr val="383A42"/>
+                </a:solidFill>
+                <a:latin typeface="Courier New"/>
+                <a:cs typeface="Courier New"/>
+              </a:rPr>
+              <a:t>glass</a:t>
+            </a:r>
+            <a:r>
+              <a:rPr lang="sv-SE" sz="1300" dirty="0">
+                <a:solidFill>
+                  <a:srgbClr val="383A42"/>
+                </a:solidFill>
+                <a:latin typeface="Courier New"/>
+                <a:cs typeface="Courier New"/>
+              </a:rPr>
+              <a:t>)</a:t>
+            </a:r>
+            <a:r>
+              <a:rPr lang="sv-SE" sz="1300" dirty="0">
+                <a:solidFill>
+                  <a:srgbClr val="383A42"/>
+                </a:solidFill>
+                <a:latin typeface="Courier New"/>
+                <a:cs typeface="Courier New"/>
+              </a:rPr>
+              <a:t>)</a:t>
+            </a:r>
+            <a:r>
+              <a:rPr lang="sv-SE" sz="1300" dirty="0">
+                <a:solidFill>
+                  <a:srgbClr val="383A42"/>
+                </a:solidFill>
+                <a:latin typeface="Courier New"/>
+                <a:cs typeface="Courier New"/>
+              </a:rPr>
+              <a:t>;</a:t>
+            </a:r>
+            <a:r>
+              <a:rPr lang="sv-SE" sz="1300" dirty="0">
+                <a:solidFill>
+                  <a:srgbClr val="383A42"/>
+                </a:solidFill>
+                <a:latin typeface="Courier New"/>
+                <a:cs typeface="Courier New"/>
+              </a:rPr>
+              <a:t xml:space="preserve">  </a:t>
+            </a:r>
+            <a:r>
+              <a:rPr lang="sv-SE" sz="1300" i="1" dirty="0">
+                <a:solidFill>
+                  <a:srgbClr val="8A8F98"/>
+                </a:solidFill>
+                <a:latin typeface="Courier New"/>
+                <a:cs typeface="Courier New"/>
+              </a:rPr>
+              <a:t>// false</a:t>
+            </a:r>
+            <a:endParaRPr lang="sv-SE" sz="1300" dirty="0"/>
           </a:p>
         </p:txBody>
       </p:sp>
       <p:sp>
         <p:nvSpPr>
-          <p:cNvPr id="20" name="Objekt glass3"/>
+          <p:cNvPr id="6" name="Kort 1"/>
           <p:cNvSpPr/>
           <p:nvPr/>
         </p:nvSpPr>
         <p:spPr>
           <a:xfrm>
-            <a:off x="9829800" y="3246120"/>
-            <a:ext cx="1645920" cy="2606040"/>
+            <a:off x="8366760" y="868680"/>
+            <a:ext cx="3383280" cy="1051560"/>
           </a:xfrm>
           <a:prstGeom prst="roundRect">
             <a:avLst>
-              <a:gd name="adj" fmla="val 7000"/>
+              <a:gd name="adj" fmla="val 9000"/>
             </a:avLst>
           </a:prstGeom>
           <a:solidFill>
@@ -16139,107 +16531,12 @@
           </a:effectLst>
         </p:spPr>
         <p:txBody>
-          <a:bodyPr wrap="square" lIns="91440" tIns="45720" rIns="91440" bIns="45720" anchor="t" rtlCol="0">
+          <a:bodyPr wrap="square" lIns="182880" tIns="109728" rIns="182880" bIns="109728" anchor="t" rtlCol="0">
             <a:noAutofit/>
           </a:bodyPr>
           <a:lstStyle/>
           <a:p>
-            <a:endParaRPr lang="sv-SE" dirty="0"/>
-          </a:p>
-        </p:txBody>
-      </p:sp>
-      <p:sp>
-        <p:nvSpPr>
-          <p:cNvPr id="21" name="Strut"/>
-          <p:cNvSpPr/>
-          <p:nvPr/>
-        </p:nvSpPr>
-        <p:spPr>
-          <a:xfrm flipV="1">
-            <a:off x="10435590" y="4444898"/>
-            <a:ext cx="434340" cy="538582"/>
-          </a:xfrm>
-          <a:prstGeom prst="triangle">
-            <a:avLst/>
-          </a:prstGeom>
-          <a:solidFill>
-            <a:srgbClr val="D9A25F"/>
-          </a:solidFill>
-          <a:ln w="12700">
-            <a:solidFill>
-              <a:srgbClr val="B7803F"/>
-            </a:solidFill>
-          </a:ln>
-        </p:spPr>
-        <p:txBody>
-          <a:bodyPr wrap="square" lIns="91440" tIns="45720" rIns="91440" bIns="45720" anchor="t" rtlCol="0">
-            <a:noAutofit/>
-          </a:bodyPr>
-          <a:lstStyle/>
-          <a:p>
-            <a:endParaRPr lang="sv-SE" dirty="0"/>
-          </a:p>
-        </p:txBody>
-      </p:sp>
-      <p:sp>
-        <p:nvSpPr>
-          <p:cNvPr id="22" name="Kula 1"/>
-          <p:cNvSpPr/>
-          <p:nvPr/>
-        </p:nvSpPr>
-        <p:spPr>
-          <a:xfrm>
-            <a:off x="10452964" y="4157192"/>
-            <a:ext cx="399593" cy="399593"/>
-          </a:xfrm>
-          <a:prstGeom prst="ellipse">
-            <a:avLst/>
-          </a:prstGeom>
-          <a:solidFill>
-            <a:srgbClr val="F6E7B8"/>
-          </a:solidFill>
-          <a:ln w="12700">
-            <a:solidFill>
-              <a:srgbClr val="FFFFFF"/>
-            </a:solidFill>
-          </a:ln>
-        </p:spPr>
-        <p:txBody>
-          <a:bodyPr wrap="square" lIns="91440" tIns="45720" rIns="91440" bIns="45720" anchor="t" rtlCol="0">
-            <a:noAutofit/>
-          </a:bodyPr>
-          <a:lstStyle/>
-          <a:p>
-            <a:endParaRPr lang="sv-SE" dirty="0"/>
-          </a:p>
-        </p:txBody>
-      </p:sp>
-      <p:sp>
-        <p:nvSpPr>
-          <p:cNvPr id="23" name="Text glass3"/>
-          <p:cNvSpPr txBox="1"/>
-          <p:nvPr/>
-        </p:nvSpPr>
-        <p:spPr>
-          <a:xfrm>
-            <a:off x="9921240" y="5074920"/>
-            <a:ext cx="1463040" cy="914400"/>
-          </a:xfrm>
-          <a:prstGeom prst="rect">
-            <a:avLst/>
-          </a:prstGeom>
-          <a:noFill/>
-          <a:ln>
-            <a:noFill/>
-          </a:ln>
-        </p:spPr>
-        <p:txBody>
-          <a:bodyPr wrap="square" lIns="0" tIns="0" rIns="0" bIns="0" anchor="t" rtlCol="0">
-            <a:noAutofit/>
-          </a:bodyPr>
-          <a:lstStyle/>
-          <a:p>
-            <a:pPr marL="0" indent="0" algn="ctr">
+            <a:pPr marL="0" indent="0" algn="l">
               <a:spcBef>
                 <a:spcPts val="0"/>
               </a:spcBef>
@@ -16249,18 +16546,74 @@
               <a:buNone/>
             </a:pPr>
             <a:r>
-              <a:rPr lang="sv-SE" sz="1300" b="1" dirty="0">
+              <a:rPr lang="sv-SE" sz="1400" b="1" dirty="0">
                 <a:solidFill>
                   <a:srgbClr val="2A1A00"/>
                 </a:solidFill>
                 <a:latin typeface="Courier New"/>
                 <a:cs typeface="Courier New"/>
               </a:rPr>
-              <a:t>glass3</a:t>
-            </a:r>
-          </a:p>
-          <a:p>
-            <a:pPr marL="0" indent="0" algn="ctr">
+              <a:t>Object.keys(obj)</a:t>
+            </a:r>
+          </a:p>
+          <a:p>
+            <a:pPr marL="0" indent="0" algn="l">
+              <a:spcBef>
+                <a:spcPts val="300"/>
+              </a:spcBef>
+              <a:spcAft>
+                <a:spcPts val="0"/>
+              </a:spcAft>
+              <a:buNone/>
+            </a:pPr>
+            <a:r>
+              <a:rPr lang="sv-SE" sz="1400" dirty="0">
+                <a:solidFill>
+                  <a:srgbClr val="404040"/>
+                </a:solidFill>
+              </a:rPr>
+              <a:t>Ger en array med alla nycklar (egenskapernas namn).</a:t>
+            </a:r>
+          </a:p>
+        </p:txBody>
+      </p:sp>
+      <p:sp>
+        <p:nvSpPr>
+          <p:cNvPr id="7" name="Kort 2"/>
+          <p:cNvSpPr/>
+          <p:nvPr/>
+        </p:nvSpPr>
+        <p:spPr>
+          <a:xfrm>
+            <a:off x="8366760" y="2103120"/>
+            <a:ext cx="3383280" cy="1051560"/>
+          </a:xfrm>
+          <a:prstGeom prst="roundRect">
+            <a:avLst>
+              <a:gd name="adj" fmla="val 9000"/>
+            </a:avLst>
+          </a:prstGeom>
+          <a:solidFill>
+            <a:srgbClr val="FFFFFF"/>
+          </a:solidFill>
+          <a:ln>
+            <a:noFill/>
+          </a:ln>
+          <a:effectLst>
+            <a:outerShdw blurRad="76200" dist="25400" dir="5400000" algn="t" rotWithShape="0">
+              <a:srgbClr val="000000">
+                <a:alpha val="18000"/>
+              </a:srgbClr>
+            </a:outerShdw>
+          </a:effectLst>
+        </p:spPr>
+        <p:txBody>
+          <a:bodyPr wrap="square" lIns="182880" tIns="109728" rIns="182880" bIns="109728" anchor="t" rtlCol="0">
+            <a:noAutofit/>
+          </a:bodyPr>
+          <a:lstStyle/>
+          <a:p>
+            <a:pPr marL="0" indent="0" algn="l">
               <a:spcBef>
                 <a:spcPts val="0"/>
               </a:spcBef>
@@ -16270,12 +16623,178 @@
               <a:buNone/>
             </a:pPr>
             <a:r>
-              <a:rPr lang="sv-SE" sz="1300" dirty="0">
+              <a:rPr lang="sv-SE" sz="1400" b="1" dirty="0">
+                <a:solidFill>
+                  <a:srgbClr val="2A1A00"/>
+                </a:solidFill>
+                <a:latin typeface="Courier New"/>
+                <a:cs typeface="Courier New"/>
+              </a:rPr>
+              <a:t>Object.values(obj)</a:t>
+            </a:r>
+          </a:p>
+          <a:p>
+            <a:pPr marL="0" indent="0" algn="l">
+              <a:spcBef>
+                <a:spcPts val="300"/>
+              </a:spcBef>
+              <a:spcAft>
+                <a:spcPts val="0"/>
+              </a:spcAft>
+              <a:buNone/>
+            </a:pPr>
+            <a:r>
+              <a:rPr lang="sv-SE" sz="1400" dirty="0">
                 <a:solidFill>
                   <a:srgbClr val="404040"/>
                 </a:solidFill>
               </a:rPr>
-              <a:t>Vanilj, 1 kula</a:t>
+              <a:t>Ger en array med alla värden.</a:t>
+            </a:r>
+          </a:p>
+        </p:txBody>
+      </p:sp>
+      <p:sp>
+        <p:nvSpPr>
+          <p:cNvPr id="8" name="Kort 3"/>
+          <p:cNvSpPr/>
+          <p:nvPr/>
+        </p:nvSpPr>
+        <p:spPr>
+          <a:xfrm>
+            <a:off x="8366760" y="3337560"/>
+            <a:ext cx="3383280" cy="1051560"/>
+          </a:xfrm>
+          <a:prstGeom prst="roundRect">
+            <a:avLst>
+              <a:gd name="adj" fmla="val 9000"/>
+            </a:avLst>
+          </a:prstGeom>
+          <a:solidFill>
+            <a:srgbClr val="FFFFFF"/>
+          </a:solidFill>
+          <a:ln>
+            <a:noFill/>
+          </a:ln>
+          <a:effectLst>
+            <a:outerShdw blurRad="76200" dist="25400" dir="5400000" algn="t" rotWithShape="0">
+              <a:srgbClr val="000000">
+                <a:alpha val="18000"/>
+              </a:srgbClr>
+            </a:outerShdw>
+          </a:effectLst>
+        </p:spPr>
+        <p:txBody>
+          <a:bodyPr wrap="square" lIns="182880" tIns="109728" rIns="182880" bIns="109728" anchor="t" rtlCol="0">
+            <a:noAutofit/>
+          </a:bodyPr>
+          <a:lstStyle/>
+          <a:p>
+            <a:pPr marL="0" indent="0" algn="l">
+              <a:spcBef>
+                <a:spcPts val="0"/>
+              </a:spcBef>
+              <a:spcAft>
+                <a:spcPts val="0"/>
+              </a:spcAft>
+              <a:buNone/>
+            </a:pPr>
+            <a:r>
+              <a:rPr lang="sv-SE" sz="1400" b="1" dirty="0">
+                <a:solidFill>
+                  <a:srgbClr val="2A1A00"/>
+                </a:solidFill>
+                <a:latin typeface="Courier New"/>
+                <a:cs typeface="Courier New"/>
+              </a:rPr>
+              <a:t>Object.entries(obj)</a:t>
+            </a:r>
+          </a:p>
+          <a:p>
+            <a:pPr marL="0" indent="0" algn="l">
+              <a:spcBef>
+                <a:spcPts val="300"/>
+              </a:spcBef>
+              <a:spcAft>
+                <a:spcPts val="0"/>
+              </a:spcAft>
+              <a:buNone/>
+            </a:pPr>
+            <a:r>
+              <a:rPr lang="sv-SE" sz="1400" dirty="0">
+                <a:solidFill>
+                  <a:srgbClr val="404040"/>
+                </a:solidFill>
+              </a:rPr>
+              <a:t>Ger en array med par: [nyckel, värde].</a:t>
+            </a:r>
+          </a:p>
+        </p:txBody>
+      </p:sp>
+      <p:sp>
+        <p:nvSpPr>
+          <p:cNvPr id="9" name="Tips tomt"/>
+          <p:cNvSpPr/>
+          <p:nvPr/>
+        </p:nvSpPr>
+        <p:spPr>
+          <a:xfrm>
+            <a:off x="8366760" y="4663440"/>
+            <a:ext cx="3383280" cy="1600200"/>
+          </a:xfrm>
+          <a:prstGeom prst="roundRect">
+            <a:avLst>
+              <a:gd name="adj" fmla="val 9000"/>
+            </a:avLst>
+          </a:prstGeom>
+          <a:solidFill>
+            <a:srgbClr val="FBE7B8"/>
+          </a:solidFill>
+          <a:ln>
+            <a:noFill/>
+          </a:ln>
+        </p:spPr>
+        <p:txBody>
+          <a:bodyPr wrap="square" lIns="182880" tIns="109728" rIns="182880" bIns="109728" anchor="ctr" rtlCol="0">
+            <a:noAutofit/>
+          </a:bodyPr>
+          <a:lstStyle/>
+          <a:p>
+            <a:pPr marL="0" indent="0" algn="l">
+              <a:spcBef>
+                <a:spcPts val="0"/>
+              </a:spcBef>
+              <a:spcAft>
+                <a:spcPts val="0"/>
+              </a:spcAft>
+              <a:buNone/>
+            </a:pPr>
+            <a:r>
+              <a:rPr lang="sv-SE" sz="1400" b="1" dirty="0">
+                <a:solidFill>
+                  <a:srgbClr val="2A1A00"/>
+                </a:solidFill>
+              </a:rPr>
+              <a:t>Tomt objekt = inga nycklar</a:t>
+            </a:r>
+          </a:p>
+          <a:p>
+            <a:pPr marL="0" indent="0" algn="l">
+              <a:spcBef>
+                <a:spcPts val="300"/>
+              </a:spcBef>
+              <a:spcAft>
+                <a:spcPts val="0"/>
+              </a:spcAft>
+              <a:buNone/>
+            </a:pPr>
+            <a:r>
+              <a:rPr lang="sv-SE" sz="1400" dirty="0">
+                <a:solidFill>
+                  <a:srgbClr val="2A1A00"/>
+                </a:solidFill>
+              </a:rPr>
+              <a:t>Ett tomt objekt {} har inga nycklar. Då blir Object.keys(obj).length lika med 0.</a:t>
             </a:r>
           </a:p>
         </p:txBody>
@@ -16331,6 +16850,1127 @@
               <a:rPr lang="sv-SE" sz="3600" dirty="0">
                 <a:latin typeface="Bodoni MT" panose="02070603080606020203" pitchFamily="18" charset="0"/>
               </a:rPr>
+              <a:t>Objektorienterad programmering</a:t>
+            </a:r>
+          </a:p>
+        </p:txBody>
+      </p:sp>
+      <p:sp>
+        <p:nvSpPr>
+          <p:cNvPr id="3" name="Begrepp"/>
+          <p:cNvSpPr txBox="1"/>
+          <p:nvPr/>
+        </p:nvSpPr>
+        <p:spPr>
+          <a:xfrm>
+            <a:off x="1207008" y="914400"/>
+            <a:ext cx="4297680" cy="5394960"/>
+          </a:xfrm>
+          <a:prstGeom prst="rect">
+            <a:avLst/>
+          </a:prstGeom>
+          <a:noFill/>
+          <a:ln>
+            <a:noFill/>
+          </a:ln>
+        </p:spPr>
+        <p:txBody>
+          <a:bodyPr wrap="square" lIns="0" tIns="0" rIns="0" bIns="0" anchor="t" rtlCol="0">
+            <a:noAutofit/>
+          </a:bodyPr>
+          <a:lstStyle/>
+          <a:p>
+            <a:pPr marL="0" indent="0" algn="l">
+              <a:spcBef>
+                <a:spcPts val="0"/>
+              </a:spcBef>
+              <a:spcAft>
+                <a:spcPts val="1000"/>
+              </a:spcAft>
+              <a:buNone/>
+            </a:pPr>
+            <a:r>
+              <a:rPr lang="sv-SE" sz="1800" dirty="0">
+                <a:solidFill>
+                  <a:srgbClr val="404040"/>
+                </a:solidFill>
+              </a:rPr>
+              <a:t>I OOP samlar vi data och funktioner som hör ihop i objekt.</a:t>
+            </a:r>
+          </a:p>
+          <a:p>
+            <a:pPr marL="0" indent="0" algn="l">
+              <a:spcBef>
+                <a:spcPts val="1000"/>
+              </a:spcBef>
+              <a:spcAft>
+                <a:spcPts val="0"/>
+              </a:spcAft>
+              <a:buNone/>
+            </a:pPr>
+            <a:r>
+              <a:rPr lang="sv-SE" sz="1700" b="1" dirty="0">
+                <a:solidFill>
+                  <a:srgbClr val="2A1A00"/>
+                </a:solidFill>
+              </a:rPr>
+              <a:t>Klass</a:t>
+            </a:r>
+          </a:p>
+          <a:p>
+            <a:pPr marL="0" indent="0" algn="l">
+              <a:spcBef>
+                <a:spcPts val="0"/>
+              </a:spcBef>
+              <a:spcAft>
+                <a:spcPts val="0"/>
+              </a:spcAft>
+              <a:buNone/>
+            </a:pPr>
+            <a:r>
+              <a:rPr lang="sv-SE" sz="1600" dirty="0">
+                <a:solidFill>
+                  <a:srgbClr val="404040"/>
+                </a:solidFill>
+              </a:rPr>
+              <a:t>En mall eller ritning, som receptet för en glass.</a:t>
+            </a:r>
+          </a:p>
+          <a:p>
+            <a:pPr marL="0" indent="0" algn="l">
+              <a:spcBef>
+                <a:spcPts val="1000"/>
+              </a:spcBef>
+              <a:spcAft>
+                <a:spcPts val="0"/>
+              </a:spcAft>
+              <a:buNone/>
+            </a:pPr>
+            <a:r>
+              <a:rPr lang="sv-SE" sz="1700" b="1" dirty="0">
+                <a:solidFill>
+                  <a:srgbClr val="2A1A00"/>
+                </a:solidFill>
+              </a:rPr>
+              <a:t>Objekt / instans</a:t>
+            </a:r>
+          </a:p>
+          <a:p>
+            <a:pPr marL="0" indent="0" algn="l">
+              <a:spcBef>
+                <a:spcPts val="0"/>
+              </a:spcBef>
+              <a:spcAft>
+                <a:spcPts val="0"/>
+              </a:spcAft>
+              <a:buNone/>
+            </a:pPr>
+            <a:r>
+              <a:rPr lang="sv-SE" sz="1600" dirty="0">
+                <a:solidFill>
+                  <a:srgbClr val="404040"/>
+                </a:solidFill>
+              </a:rPr>
+              <a:t>En riktig glass som skapas från klassen.</a:t>
+            </a:r>
+          </a:p>
+          <a:p>
+            <a:pPr marL="0" indent="0" algn="l">
+              <a:spcBef>
+                <a:spcPts val="1000"/>
+              </a:spcBef>
+              <a:spcAft>
+                <a:spcPts val="0"/>
+              </a:spcAft>
+              <a:buNone/>
+            </a:pPr>
+            <a:r>
+              <a:rPr lang="sv-SE" sz="1700" b="1" dirty="0">
+                <a:solidFill>
+                  <a:srgbClr val="2A1A00"/>
+                </a:solidFill>
+              </a:rPr>
+              <a:t>Egenskaper</a:t>
+            </a:r>
+          </a:p>
+          <a:p>
+            <a:pPr marL="0" indent="0" algn="l">
+              <a:spcBef>
+                <a:spcPts val="0"/>
+              </a:spcBef>
+              <a:spcAft>
+                <a:spcPts val="0"/>
+              </a:spcAft>
+              <a:buNone/>
+            </a:pPr>
+            <a:r>
+              <a:rPr lang="sv-SE" sz="1600" dirty="0">
+                <a:solidFill>
+                  <a:srgbClr val="404040"/>
+                </a:solidFill>
+              </a:rPr>
+              <a:t>Data som objektet har, t.ex. smak och kulor.</a:t>
+            </a:r>
+          </a:p>
+          <a:p>
+            <a:pPr marL="0" indent="0" algn="l">
+              <a:spcBef>
+                <a:spcPts val="1000"/>
+              </a:spcBef>
+              <a:spcAft>
+                <a:spcPts val="0"/>
+              </a:spcAft>
+              <a:buNone/>
+            </a:pPr>
+            <a:r>
+              <a:rPr lang="sv-SE" sz="1700" b="1" dirty="0">
+                <a:solidFill>
+                  <a:srgbClr val="2A1A00"/>
+                </a:solidFill>
+              </a:rPr>
+              <a:t>Metoder</a:t>
+            </a:r>
+          </a:p>
+          <a:p>
+            <a:pPr marL="0" indent="0" algn="l">
+              <a:spcBef>
+                <a:spcPts val="0"/>
+              </a:spcBef>
+              <a:spcAft>
+                <a:spcPts val="0"/>
+              </a:spcAft>
+              <a:buNone/>
+            </a:pPr>
+            <a:r>
+              <a:rPr lang="sv-SE" sz="1600" dirty="0">
+                <a:solidFill>
+                  <a:srgbClr val="404040"/>
+                </a:solidFill>
+              </a:rPr>
+              <a:t>Saker objektet kan göra, t.ex. beskriv().</a:t>
+            </a:r>
+          </a:p>
+          <a:p>
+            <a:pPr marL="0" indent="0" algn="l">
+              <a:spcBef>
+                <a:spcPts val="1800"/>
+              </a:spcBef>
+              <a:spcAft>
+                <a:spcPts val="0"/>
+              </a:spcAft>
+              <a:buNone/>
+            </a:pPr>
+            <a:r>
+              <a:rPr lang="sv-SE" sz="1600" i="1" dirty="0">
+                <a:solidFill>
+                  <a:srgbClr val="6B6B6B"/>
+                </a:solidFill>
+              </a:rPr>
+              <a:t>En klass, många objekt. Varje objekt har sina egna värden.</a:t>
+            </a:r>
+          </a:p>
+        </p:txBody>
+      </p:sp>
+      <p:sp>
+        <p:nvSpPr>
+          <p:cNvPr id="4" name="Klass Glass"/>
+          <p:cNvSpPr/>
+          <p:nvPr/>
+        </p:nvSpPr>
+        <p:spPr>
+          <a:xfrm>
+            <a:off x="6766560" y="914400"/>
+            <a:ext cx="3840480" cy="1417320"/>
+          </a:xfrm>
+          <a:prstGeom prst="roundRect">
+            <a:avLst>
+              <a:gd name="adj" fmla="val 8000"/>
+            </a:avLst>
+          </a:prstGeom>
+          <a:solidFill>
+            <a:srgbClr val="F8B323"/>
+          </a:solidFill>
+          <a:ln>
+            <a:noFill/>
+          </a:ln>
+          <a:effectLst>
+            <a:outerShdw blurRad="76200" dist="25400" dir="5400000" algn="t" rotWithShape="0">
+              <a:srgbClr val="000000">
+                <a:alpha val="18000"/>
+              </a:srgbClr>
+            </a:outerShdw>
+          </a:effectLst>
+        </p:spPr>
+        <p:txBody>
+          <a:bodyPr wrap="square" lIns="182880" tIns="73152" rIns="182880" bIns="73152" anchor="ctr" rtlCol="0">
+            <a:noAutofit/>
+          </a:bodyPr>
+          <a:lstStyle/>
+          <a:p>
+            <a:pPr marL="0" indent="0" algn="ctr">
+              <a:spcBef>
+                <a:spcPts val="0"/>
+              </a:spcBef>
+              <a:spcAft>
+                <a:spcPts val="0"/>
+              </a:spcAft>
+              <a:buNone/>
+            </a:pPr>
+            <a:r>
+              <a:rPr lang="sv-SE" sz="1100" b="1" dirty="0">
+                <a:solidFill>
+                  <a:srgbClr val="2A1A00"/>
+                </a:solidFill>
+              </a:rPr>
+              <a:t>KLASS</a:t>
+            </a:r>
+          </a:p>
+          <a:p>
+            <a:pPr marL="0" indent="0" algn="ctr">
+              <a:spcBef>
+                <a:spcPts val="0"/>
+              </a:spcBef>
+              <a:spcAft>
+                <a:spcPts val="0"/>
+              </a:spcAft>
+              <a:buNone/>
+            </a:pPr>
+            <a:r>
+              <a:rPr lang="sv-SE" sz="2400" b="1" dirty="0">
+                <a:solidFill>
+                  <a:srgbClr val="2A1A00"/>
+                </a:solidFill>
+              </a:rPr>
+              <a:t>Glass</a:t>
+            </a:r>
+          </a:p>
+          <a:p>
+            <a:pPr marL="0" indent="0" algn="ctr">
+              <a:spcBef>
+                <a:spcPts val="0"/>
+              </a:spcBef>
+              <a:spcAft>
+                <a:spcPts val="0"/>
+              </a:spcAft>
+              <a:buNone/>
+            </a:pPr>
+            <a:r>
+              <a:rPr lang="sv-SE" sz="1200" dirty="0">
+                <a:solidFill>
+                  <a:srgbClr val="2A1A00"/>
+                </a:solidFill>
+                <a:latin typeface="Courier New"/>
+                <a:cs typeface="Courier New"/>
+              </a:rPr>
+              <a:t>smak · kulor · pris() · beskriv()</a:t>
+            </a:r>
+          </a:p>
+        </p:txBody>
+      </p:sp>
+      <p:sp>
+        <p:nvSpPr>
+          <p:cNvPr id="5" name="Pil"/>
+          <p:cNvSpPr/>
+          <p:nvPr/>
+        </p:nvSpPr>
+        <p:spPr>
+          <a:xfrm>
+            <a:off x="6611112" y="2450592"/>
+            <a:ext cx="219456" cy="411480"/>
+          </a:xfrm>
+          <a:prstGeom prst="downArrow">
+            <a:avLst/>
+          </a:prstGeom>
+          <a:solidFill>
+            <a:srgbClr val="B8B8B6"/>
+          </a:solidFill>
+          <a:ln>
+            <a:noFill/>
+          </a:ln>
+        </p:spPr>
+        <p:txBody>
+          <a:bodyPr wrap="square" lIns="91440" tIns="45720" rIns="91440" bIns="45720" anchor="t" rtlCol="0">
+            <a:noAutofit/>
+          </a:bodyPr>
+          <a:lstStyle/>
+          <a:p>
+            <a:endParaRPr lang="sv-SE" dirty="0"/>
+          </a:p>
+        </p:txBody>
+      </p:sp>
+      <p:sp>
+        <p:nvSpPr>
+          <p:cNvPr id="6" name="Pil"/>
+          <p:cNvSpPr/>
+          <p:nvPr/>
+        </p:nvSpPr>
+        <p:spPr>
+          <a:xfrm>
+            <a:off x="8577072" y="2450592"/>
+            <a:ext cx="219456" cy="411480"/>
+          </a:xfrm>
+          <a:prstGeom prst="downArrow">
+            <a:avLst/>
+          </a:prstGeom>
+          <a:solidFill>
+            <a:srgbClr val="B8B8B6"/>
+          </a:solidFill>
+          <a:ln>
+            <a:noFill/>
+          </a:ln>
+        </p:spPr>
+        <p:txBody>
+          <a:bodyPr wrap="square" lIns="91440" tIns="45720" rIns="91440" bIns="45720" anchor="t" rtlCol="0">
+            <a:noAutofit/>
+          </a:bodyPr>
+          <a:lstStyle/>
+          <a:p>
+            <a:endParaRPr lang="sv-SE" dirty="0"/>
+          </a:p>
+        </p:txBody>
+      </p:sp>
+      <p:sp>
+        <p:nvSpPr>
+          <p:cNvPr id="7" name="Pil"/>
+          <p:cNvSpPr/>
+          <p:nvPr/>
+        </p:nvSpPr>
+        <p:spPr>
+          <a:xfrm>
+            <a:off x="10543032" y="2450592"/>
+            <a:ext cx="219456" cy="411480"/>
+          </a:xfrm>
+          <a:prstGeom prst="downArrow">
+            <a:avLst/>
+          </a:prstGeom>
+          <a:solidFill>
+            <a:srgbClr val="B8B8B6"/>
+          </a:solidFill>
+          <a:ln>
+            <a:noFill/>
+          </a:ln>
+        </p:spPr>
+        <p:txBody>
+          <a:bodyPr wrap="square" lIns="91440" tIns="45720" rIns="91440" bIns="45720" anchor="t" rtlCol="0">
+            <a:noAutofit/>
+          </a:bodyPr>
+          <a:lstStyle/>
+          <a:p>
+            <a:endParaRPr lang="sv-SE" dirty="0"/>
+          </a:p>
+        </p:txBody>
+      </p:sp>
+      <p:sp>
+        <p:nvSpPr>
+          <p:cNvPr id="8" name="Etikett new"/>
+          <p:cNvSpPr txBox="1"/>
+          <p:nvPr/>
+        </p:nvSpPr>
+        <p:spPr>
+          <a:xfrm>
+            <a:off x="5897880" y="2880360"/>
+            <a:ext cx="5577840" cy="274320"/>
+          </a:xfrm>
+          <a:prstGeom prst="rect">
+            <a:avLst/>
+          </a:prstGeom>
+          <a:noFill/>
+          <a:ln>
+            <a:noFill/>
+          </a:ln>
+        </p:spPr>
+        <p:txBody>
+          <a:bodyPr wrap="square" lIns="0" tIns="0" rIns="0" bIns="0" anchor="t" rtlCol="0">
+            <a:noAutofit/>
+          </a:bodyPr>
+          <a:lstStyle/>
+          <a:p>
+            <a:pPr marL="0" indent="0" algn="ctr">
+              <a:spcBef>
+                <a:spcPts val="0"/>
+              </a:spcBef>
+              <a:spcAft>
+                <a:spcPts val="0"/>
+              </a:spcAft>
+              <a:buNone/>
+            </a:pPr>
+            <a:r>
+              <a:rPr lang="sv-SE" sz="1200" i="1" dirty="0">
+                <a:solidFill>
+                  <a:srgbClr val="6B6B6B"/>
+                </a:solidFill>
+              </a:rPr>
+              <a:t>skapar objekt (instanser)</a:t>
+            </a:r>
+          </a:p>
+        </p:txBody>
+      </p:sp>
+      <p:sp>
+        <p:nvSpPr>
+          <p:cNvPr id="9" name="Objekt glass1"/>
+          <p:cNvSpPr/>
+          <p:nvPr/>
+        </p:nvSpPr>
+        <p:spPr>
+          <a:xfrm>
+            <a:off x="5897880" y="3246120"/>
+            <a:ext cx="1645920" cy="2606040"/>
+          </a:xfrm>
+          <a:prstGeom prst="roundRect">
+            <a:avLst>
+              <a:gd name="adj" fmla="val 7000"/>
+            </a:avLst>
+          </a:prstGeom>
+          <a:solidFill>
+            <a:srgbClr val="FFFFFF"/>
+          </a:solidFill>
+          <a:ln>
+            <a:noFill/>
+          </a:ln>
+          <a:effectLst>
+            <a:outerShdw blurRad="76200" dist="25400" dir="5400000" algn="t" rotWithShape="0">
+              <a:srgbClr val="000000">
+                <a:alpha val="18000"/>
+              </a:srgbClr>
+            </a:outerShdw>
+          </a:effectLst>
+        </p:spPr>
+        <p:txBody>
+          <a:bodyPr wrap="square" lIns="91440" tIns="45720" rIns="91440" bIns="45720" anchor="t" rtlCol="0">
+            <a:noAutofit/>
+          </a:bodyPr>
+          <a:lstStyle/>
+          <a:p>
+            <a:endParaRPr lang="sv-SE" dirty="0"/>
+          </a:p>
+        </p:txBody>
+      </p:sp>
+      <p:sp>
+        <p:nvSpPr>
+          <p:cNvPr id="10" name="Strut"/>
+          <p:cNvSpPr/>
+          <p:nvPr/>
+        </p:nvSpPr>
+        <p:spPr>
+          <a:xfrm flipV="1">
+            <a:off x="6503670" y="4444898"/>
+            <a:ext cx="434340" cy="538582"/>
+          </a:xfrm>
+          <a:prstGeom prst="triangle">
+            <a:avLst/>
+          </a:prstGeom>
+          <a:solidFill>
+            <a:srgbClr val="D9A25F"/>
+          </a:solidFill>
+          <a:ln w="12700">
+            <a:solidFill>
+              <a:srgbClr val="B7803F"/>
+            </a:solidFill>
+          </a:ln>
+        </p:spPr>
+        <p:txBody>
+          <a:bodyPr wrap="square" lIns="91440" tIns="45720" rIns="91440" bIns="45720" anchor="t" rtlCol="0">
+            <a:noAutofit/>
+          </a:bodyPr>
+          <a:lstStyle/>
+          <a:p>
+            <a:endParaRPr lang="sv-SE" dirty="0"/>
+          </a:p>
+        </p:txBody>
+      </p:sp>
+      <p:sp>
+        <p:nvSpPr>
+          <p:cNvPr id="11" name="Kula 1"/>
+          <p:cNvSpPr/>
+          <p:nvPr/>
+        </p:nvSpPr>
+        <p:spPr>
+          <a:xfrm>
+            <a:off x="6521044" y="4157192"/>
+            <a:ext cx="399593" cy="399593"/>
+          </a:xfrm>
+          <a:prstGeom prst="ellipse">
+            <a:avLst/>
+          </a:prstGeom>
+          <a:solidFill>
+            <a:srgbClr val="6B3E26"/>
+          </a:solidFill>
+          <a:ln w="12700">
+            <a:solidFill>
+              <a:srgbClr val="FFFFFF"/>
+            </a:solidFill>
+          </a:ln>
+        </p:spPr>
+        <p:txBody>
+          <a:bodyPr wrap="square" lIns="91440" tIns="45720" rIns="91440" bIns="45720" anchor="t" rtlCol="0">
+            <a:noAutofit/>
+          </a:bodyPr>
+          <a:lstStyle/>
+          <a:p>
+            <a:endParaRPr lang="sv-SE" dirty="0"/>
+          </a:p>
+        </p:txBody>
+      </p:sp>
+      <p:sp>
+        <p:nvSpPr>
+          <p:cNvPr id="12" name="Kula 2"/>
+          <p:cNvSpPr/>
+          <p:nvPr/>
+        </p:nvSpPr>
+        <p:spPr>
+          <a:xfrm>
+            <a:off x="6521044" y="3909444"/>
+            <a:ext cx="399593" cy="399593"/>
+          </a:xfrm>
+          <a:prstGeom prst="ellipse">
+            <a:avLst/>
+          </a:prstGeom>
+          <a:solidFill>
+            <a:srgbClr val="6B3E26"/>
+          </a:solidFill>
+          <a:ln w="12700">
+            <a:solidFill>
+              <a:srgbClr val="FFFFFF"/>
+            </a:solidFill>
+          </a:ln>
+        </p:spPr>
+        <p:txBody>
+          <a:bodyPr wrap="square" lIns="91440" tIns="45720" rIns="91440" bIns="45720" anchor="t" rtlCol="0">
+            <a:noAutofit/>
+          </a:bodyPr>
+          <a:lstStyle/>
+          <a:p>
+            <a:endParaRPr lang="sv-SE" dirty="0"/>
+          </a:p>
+        </p:txBody>
+      </p:sp>
+      <p:sp>
+        <p:nvSpPr>
+          <p:cNvPr id="13" name="Text glass1"/>
+          <p:cNvSpPr txBox="1"/>
+          <p:nvPr/>
+        </p:nvSpPr>
+        <p:spPr>
+          <a:xfrm>
+            <a:off x="5989320" y="5074920"/>
+            <a:ext cx="1463040" cy="914400"/>
+          </a:xfrm>
+          <a:prstGeom prst="rect">
+            <a:avLst/>
+          </a:prstGeom>
+          <a:noFill/>
+          <a:ln>
+            <a:noFill/>
+          </a:ln>
+        </p:spPr>
+        <p:txBody>
+          <a:bodyPr wrap="square" lIns="0" tIns="0" rIns="0" bIns="0" anchor="t" rtlCol="0">
+            <a:noAutofit/>
+          </a:bodyPr>
+          <a:lstStyle/>
+          <a:p>
+            <a:pPr marL="0" indent="0" algn="ctr">
+              <a:spcBef>
+                <a:spcPts val="0"/>
+              </a:spcBef>
+              <a:spcAft>
+                <a:spcPts val="0"/>
+              </a:spcAft>
+              <a:buNone/>
+            </a:pPr>
+            <a:r>
+              <a:rPr lang="sv-SE" sz="1300" b="1" dirty="0">
+                <a:solidFill>
+                  <a:srgbClr val="2A1A00"/>
+                </a:solidFill>
+                <a:latin typeface="Courier New"/>
+                <a:cs typeface="Courier New"/>
+              </a:rPr>
+              <a:t>glass1</a:t>
+            </a:r>
+          </a:p>
+          <a:p>
+            <a:pPr marL="0" indent="0" algn="ctr">
+              <a:spcBef>
+                <a:spcPts val="0"/>
+              </a:spcBef>
+              <a:spcAft>
+                <a:spcPts val="0"/>
+              </a:spcAft>
+              <a:buNone/>
+            </a:pPr>
+            <a:r>
+              <a:rPr lang="sv-SE" sz="1300" dirty="0">
+                <a:solidFill>
+                  <a:srgbClr val="404040"/>
+                </a:solidFill>
+              </a:rPr>
+              <a:t>Choklad, 2 kulor</a:t>
+            </a:r>
+          </a:p>
+        </p:txBody>
+      </p:sp>
+      <p:sp>
+        <p:nvSpPr>
+          <p:cNvPr id="14" name="Objekt glass2"/>
+          <p:cNvSpPr/>
+          <p:nvPr/>
+        </p:nvSpPr>
+        <p:spPr>
+          <a:xfrm>
+            <a:off x="7863840" y="3246120"/>
+            <a:ext cx="1645920" cy="2606040"/>
+          </a:xfrm>
+          <a:prstGeom prst="roundRect">
+            <a:avLst>
+              <a:gd name="adj" fmla="val 7000"/>
+            </a:avLst>
+          </a:prstGeom>
+          <a:solidFill>
+            <a:srgbClr val="FFFFFF"/>
+          </a:solidFill>
+          <a:ln>
+            <a:noFill/>
+          </a:ln>
+          <a:effectLst>
+            <a:outerShdw blurRad="76200" dist="25400" dir="5400000" algn="t" rotWithShape="0">
+              <a:srgbClr val="000000">
+                <a:alpha val="18000"/>
+              </a:srgbClr>
+            </a:outerShdw>
+          </a:effectLst>
+        </p:spPr>
+        <p:txBody>
+          <a:bodyPr wrap="square" lIns="91440" tIns="45720" rIns="91440" bIns="45720" anchor="t" rtlCol="0">
+            <a:noAutofit/>
+          </a:bodyPr>
+          <a:lstStyle/>
+          <a:p>
+            <a:endParaRPr lang="sv-SE" dirty="0"/>
+          </a:p>
+        </p:txBody>
+      </p:sp>
+      <p:sp>
+        <p:nvSpPr>
+          <p:cNvPr id="15" name="Strut"/>
+          <p:cNvSpPr/>
+          <p:nvPr/>
+        </p:nvSpPr>
+        <p:spPr>
+          <a:xfrm flipV="1">
+            <a:off x="8469630" y="4444898"/>
+            <a:ext cx="434340" cy="538582"/>
+          </a:xfrm>
+          <a:prstGeom prst="triangle">
+            <a:avLst/>
+          </a:prstGeom>
+          <a:solidFill>
+            <a:srgbClr val="D9A25F"/>
+          </a:solidFill>
+          <a:ln w="12700">
+            <a:solidFill>
+              <a:srgbClr val="B7803F"/>
+            </a:solidFill>
+          </a:ln>
+        </p:spPr>
+        <p:txBody>
+          <a:bodyPr wrap="square" lIns="91440" tIns="45720" rIns="91440" bIns="45720" anchor="t" rtlCol="0">
+            <a:noAutofit/>
+          </a:bodyPr>
+          <a:lstStyle/>
+          <a:p>
+            <a:endParaRPr lang="sv-SE" dirty="0"/>
+          </a:p>
+        </p:txBody>
+      </p:sp>
+      <p:sp>
+        <p:nvSpPr>
+          <p:cNvPr id="16" name="Kula 1"/>
+          <p:cNvSpPr/>
+          <p:nvPr/>
+        </p:nvSpPr>
+        <p:spPr>
+          <a:xfrm>
+            <a:off x="8487004" y="4157192"/>
+            <a:ext cx="399593" cy="399593"/>
+          </a:xfrm>
+          <a:prstGeom prst="ellipse">
+            <a:avLst/>
+          </a:prstGeom>
+          <a:solidFill>
+            <a:srgbClr val="F29CB3"/>
+          </a:solidFill>
+          <a:ln w="12700">
+            <a:solidFill>
+              <a:srgbClr val="FFFFFF"/>
+            </a:solidFill>
+          </a:ln>
+        </p:spPr>
+        <p:txBody>
+          <a:bodyPr wrap="square" lIns="91440" tIns="45720" rIns="91440" bIns="45720" anchor="t" rtlCol="0">
+            <a:noAutofit/>
+          </a:bodyPr>
+          <a:lstStyle/>
+          <a:p>
+            <a:endParaRPr lang="sv-SE" dirty="0"/>
+          </a:p>
+        </p:txBody>
+      </p:sp>
+      <p:sp>
+        <p:nvSpPr>
+          <p:cNvPr id="17" name="Kula 2"/>
+          <p:cNvSpPr/>
+          <p:nvPr/>
+        </p:nvSpPr>
+        <p:spPr>
+          <a:xfrm>
+            <a:off x="8487004" y="3909444"/>
+            <a:ext cx="399593" cy="399593"/>
+          </a:xfrm>
+          <a:prstGeom prst="ellipse">
+            <a:avLst/>
+          </a:prstGeom>
+          <a:solidFill>
+            <a:srgbClr val="F29CB3"/>
+          </a:solidFill>
+          <a:ln w="12700">
+            <a:solidFill>
+              <a:srgbClr val="FFFFFF"/>
+            </a:solidFill>
+          </a:ln>
+        </p:spPr>
+        <p:txBody>
+          <a:bodyPr wrap="square" lIns="91440" tIns="45720" rIns="91440" bIns="45720" anchor="t" rtlCol="0">
+            <a:noAutofit/>
+          </a:bodyPr>
+          <a:lstStyle/>
+          <a:p>
+            <a:endParaRPr lang="sv-SE" dirty="0"/>
+          </a:p>
+        </p:txBody>
+      </p:sp>
+      <p:sp>
+        <p:nvSpPr>
+          <p:cNvPr id="18" name="Kula 3"/>
+          <p:cNvSpPr/>
+          <p:nvPr/>
+        </p:nvSpPr>
+        <p:spPr>
+          <a:xfrm>
+            <a:off x="8487004" y="3661697"/>
+            <a:ext cx="399593" cy="399593"/>
+          </a:xfrm>
+          <a:prstGeom prst="ellipse">
+            <a:avLst/>
+          </a:prstGeom>
+          <a:solidFill>
+            <a:srgbClr val="F29CB3"/>
+          </a:solidFill>
+          <a:ln w="12700">
+            <a:solidFill>
+              <a:srgbClr val="FFFFFF"/>
+            </a:solidFill>
+          </a:ln>
+        </p:spPr>
+        <p:txBody>
+          <a:bodyPr wrap="square" lIns="91440" tIns="45720" rIns="91440" bIns="45720" anchor="t" rtlCol="0">
+            <a:noAutofit/>
+          </a:bodyPr>
+          <a:lstStyle/>
+          <a:p>
+            <a:endParaRPr lang="sv-SE" dirty="0"/>
+          </a:p>
+        </p:txBody>
+      </p:sp>
+      <p:sp>
+        <p:nvSpPr>
+          <p:cNvPr id="19" name="Text glass2"/>
+          <p:cNvSpPr txBox="1"/>
+          <p:nvPr/>
+        </p:nvSpPr>
+        <p:spPr>
+          <a:xfrm>
+            <a:off x="7955280" y="5074920"/>
+            <a:ext cx="1463040" cy="914400"/>
+          </a:xfrm>
+          <a:prstGeom prst="rect">
+            <a:avLst/>
+          </a:prstGeom>
+          <a:noFill/>
+          <a:ln>
+            <a:noFill/>
+          </a:ln>
+        </p:spPr>
+        <p:txBody>
+          <a:bodyPr wrap="square" lIns="0" tIns="0" rIns="0" bIns="0" anchor="t" rtlCol="0">
+            <a:noAutofit/>
+          </a:bodyPr>
+          <a:lstStyle/>
+          <a:p>
+            <a:pPr marL="0" indent="0" algn="ctr">
+              <a:spcBef>
+                <a:spcPts val="0"/>
+              </a:spcBef>
+              <a:spcAft>
+                <a:spcPts val="0"/>
+              </a:spcAft>
+              <a:buNone/>
+            </a:pPr>
+            <a:r>
+              <a:rPr lang="sv-SE" sz="1300" b="1" dirty="0">
+                <a:solidFill>
+                  <a:srgbClr val="2A1A00"/>
+                </a:solidFill>
+                <a:latin typeface="Courier New"/>
+                <a:cs typeface="Courier New"/>
+              </a:rPr>
+              <a:t>glass2</a:t>
+            </a:r>
+          </a:p>
+          <a:p>
+            <a:pPr marL="0" indent="0" algn="ctr">
+              <a:spcBef>
+                <a:spcPts val="0"/>
+              </a:spcBef>
+              <a:spcAft>
+                <a:spcPts val="0"/>
+              </a:spcAft>
+              <a:buNone/>
+            </a:pPr>
+            <a:r>
+              <a:rPr lang="sv-SE" sz="1300" dirty="0">
+                <a:solidFill>
+                  <a:srgbClr val="404040"/>
+                </a:solidFill>
+              </a:rPr>
+              <a:t>Jordgubb, 3 kulor</a:t>
+            </a:r>
+          </a:p>
+        </p:txBody>
+      </p:sp>
+      <p:sp>
+        <p:nvSpPr>
+          <p:cNvPr id="20" name="Objekt glass3"/>
+          <p:cNvSpPr/>
+          <p:nvPr/>
+        </p:nvSpPr>
+        <p:spPr>
+          <a:xfrm>
+            <a:off x="9829800" y="3246120"/>
+            <a:ext cx="1645920" cy="2606040"/>
+          </a:xfrm>
+          <a:prstGeom prst="roundRect">
+            <a:avLst>
+              <a:gd name="adj" fmla="val 7000"/>
+            </a:avLst>
+          </a:prstGeom>
+          <a:solidFill>
+            <a:srgbClr val="FFFFFF"/>
+          </a:solidFill>
+          <a:ln>
+            <a:noFill/>
+          </a:ln>
+          <a:effectLst>
+            <a:outerShdw blurRad="76200" dist="25400" dir="5400000" algn="t" rotWithShape="0">
+              <a:srgbClr val="000000">
+                <a:alpha val="18000"/>
+              </a:srgbClr>
+            </a:outerShdw>
+          </a:effectLst>
+        </p:spPr>
+        <p:txBody>
+          <a:bodyPr wrap="square" lIns="91440" tIns="45720" rIns="91440" bIns="45720" anchor="t" rtlCol="0">
+            <a:noAutofit/>
+          </a:bodyPr>
+          <a:lstStyle/>
+          <a:p>
+            <a:endParaRPr lang="sv-SE" dirty="0"/>
+          </a:p>
+        </p:txBody>
+      </p:sp>
+      <p:sp>
+        <p:nvSpPr>
+          <p:cNvPr id="21" name="Strut"/>
+          <p:cNvSpPr/>
+          <p:nvPr/>
+        </p:nvSpPr>
+        <p:spPr>
+          <a:xfrm flipV="1">
+            <a:off x="10435590" y="4444898"/>
+            <a:ext cx="434340" cy="538582"/>
+          </a:xfrm>
+          <a:prstGeom prst="triangle">
+            <a:avLst/>
+          </a:prstGeom>
+          <a:solidFill>
+            <a:srgbClr val="D9A25F"/>
+          </a:solidFill>
+          <a:ln w="12700">
+            <a:solidFill>
+              <a:srgbClr val="B7803F"/>
+            </a:solidFill>
+          </a:ln>
+        </p:spPr>
+        <p:txBody>
+          <a:bodyPr wrap="square" lIns="91440" tIns="45720" rIns="91440" bIns="45720" anchor="t" rtlCol="0">
+            <a:noAutofit/>
+          </a:bodyPr>
+          <a:lstStyle/>
+          <a:p>
+            <a:endParaRPr lang="sv-SE" dirty="0"/>
+          </a:p>
+        </p:txBody>
+      </p:sp>
+      <p:sp>
+        <p:nvSpPr>
+          <p:cNvPr id="22" name="Kula 1"/>
+          <p:cNvSpPr/>
+          <p:nvPr/>
+        </p:nvSpPr>
+        <p:spPr>
+          <a:xfrm>
+            <a:off x="10452964" y="4157192"/>
+            <a:ext cx="399593" cy="399593"/>
+          </a:xfrm>
+          <a:prstGeom prst="ellipse">
+            <a:avLst/>
+          </a:prstGeom>
+          <a:solidFill>
+            <a:srgbClr val="F6E7B8"/>
+          </a:solidFill>
+          <a:ln w="12700">
+            <a:solidFill>
+              <a:srgbClr val="FFFFFF"/>
+            </a:solidFill>
+          </a:ln>
+        </p:spPr>
+        <p:txBody>
+          <a:bodyPr wrap="square" lIns="91440" tIns="45720" rIns="91440" bIns="45720" anchor="t" rtlCol="0">
+            <a:noAutofit/>
+          </a:bodyPr>
+          <a:lstStyle/>
+          <a:p>
+            <a:endParaRPr lang="sv-SE" dirty="0"/>
+          </a:p>
+        </p:txBody>
+      </p:sp>
+      <p:sp>
+        <p:nvSpPr>
+          <p:cNvPr id="23" name="Text glass3"/>
+          <p:cNvSpPr txBox="1"/>
+          <p:nvPr/>
+        </p:nvSpPr>
+        <p:spPr>
+          <a:xfrm>
+            <a:off x="9921240" y="5074920"/>
+            <a:ext cx="1463040" cy="914400"/>
+          </a:xfrm>
+          <a:prstGeom prst="rect">
+            <a:avLst/>
+          </a:prstGeom>
+          <a:noFill/>
+          <a:ln>
+            <a:noFill/>
+          </a:ln>
+        </p:spPr>
+        <p:txBody>
+          <a:bodyPr wrap="square" lIns="0" tIns="0" rIns="0" bIns="0" anchor="t" rtlCol="0">
+            <a:noAutofit/>
+          </a:bodyPr>
+          <a:lstStyle/>
+          <a:p>
+            <a:pPr marL="0" indent="0" algn="ctr">
+              <a:spcBef>
+                <a:spcPts val="0"/>
+              </a:spcBef>
+              <a:spcAft>
+                <a:spcPts val="0"/>
+              </a:spcAft>
+              <a:buNone/>
+            </a:pPr>
+            <a:r>
+              <a:rPr lang="sv-SE" sz="1300" b="1" dirty="0">
+                <a:solidFill>
+                  <a:srgbClr val="2A1A00"/>
+                </a:solidFill>
+                <a:latin typeface="Courier New"/>
+                <a:cs typeface="Courier New"/>
+              </a:rPr>
+              <a:t>glass3</a:t>
+            </a:r>
+          </a:p>
+          <a:p>
+            <a:pPr marL="0" indent="0" algn="ctr">
+              <a:spcBef>
+                <a:spcPts val="0"/>
+              </a:spcBef>
+              <a:spcAft>
+                <a:spcPts val="0"/>
+              </a:spcAft>
+              <a:buNone/>
+            </a:pPr>
+            <a:r>
+              <a:rPr lang="sv-SE" sz="1300" dirty="0">
+                <a:solidFill>
+                  <a:srgbClr val="404040"/>
+                </a:solidFill>
+              </a:rPr>
+              <a:t>Vanilj, 1 kula</a:t>
+            </a:r>
+          </a:p>
+        </p:txBody>
+      </p:sp>
+    </p:spTree>
+  </p:cSld>
+  <p:clrMapOvr>
+    <a:masterClrMapping/>
+  </p:clrMapOvr>
+</p:sld>
+</file>
+
+<file path=ppt/slides/slide24.xml><?xml version="1.0" encoding="utf-8"?>
+<p:sld xmlns:a="http://schemas.openxmlformats.org/drawingml/2006/main" xmlns:r="http://schemas.openxmlformats.org/officeDocument/2006/relationships" xmlns:p="http://schemas.openxmlformats.org/presentationml/2006/main">
+  <p:cSld>
+    <p:spTree>
+      <p:nvGrpSpPr>
+        <p:cNvPr id="1" name=""/>
+        <p:cNvGrpSpPr/>
+        <p:nvPr/>
+      </p:nvGrpSpPr>
+      <p:grpSpPr>
+        <a:xfrm>
+          <a:off x="0" y="0"/>
+          <a:ext cx="0" cy="0"/>
+          <a:chOff x="0" y="0"/>
+          <a:chExt cx="0" cy="0"/>
+        </a:xfrm>
+      </p:grpSpPr>
+      <p:sp>
+        <p:nvSpPr>
+          <p:cNvPr id="2" name="Title 1"/>
+          <p:cNvSpPr>
+            <a:spLocks noGrp="1"/>
+          </p:cNvSpPr>
+          <p:nvPr>
+            <p:ph type="title"/>
+          </p:nvPr>
+        </p:nvSpPr>
+        <p:spPr>
+          <a:xfrm>
+            <a:off x="1203434" y="83247"/>
+            <a:ext cx="10893973" cy="596023"/>
+          </a:xfrm>
+        </p:spPr>
+        <p:txBody>
+          <a:bodyPr>
+            <a:normAutofit/>
+          </a:bodyPr>
+          <a:lstStyle/>
+          <a:p>
+            <a:r>
+              <a:rPr lang="sv-SE" sz="3600" dirty="0">
+                <a:latin typeface="Bodoni MT" panose="02070603080606020203" pitchFamily="18" charset="0"/>
+              </a:rPr>
               <a:t>Skapa en klass – Glass</a:t>
             </a:r>
           </a:p>
@@ -18181,7 +19821,7 @@
 </p:sld>
 </file>
 
-<file path=ppt/slides/slide24.xml><?xml version="1.0" encoding="utf-8"?>
+<file path=ppt/slides/slide25.xml><?xml version="1.0" encoding="utf-8"?>
 <p:sld xmlns:a="http://schemas.openxmlformats.org/drawingml/2006/main" xmlns:r="http://schemas.openxmlformats.org/officeDocument/2006/relationships" xmlns:p="http://schemas.openxmlformats.org/presentationml/2006/main">
   <p:cSld>
     <p:spTree>

</xml_diff>